<commit_message>
Topic 3 deck: add images into the placeholders
AWS Pricing Calculator screenshot (and related visuals) transferred into the placeholder slots. Deck 0.38 MB.

Co-Authored-By: Claude Opus 4.8 (1M context) <noreply@anthropic.com>
</commit_message>
<xml_diff>
--- a/S1-CL1-Cloud-Design-Build/delivery/topic_03/Topic_03_Slides.pptx
+++ b/S1-CL1-Cloud-Design-Build/delivery/topic_03/Topic_03_Slides.pptx
@@ -4,35 +4,38 @@
   <p:sldMasterIdLst>
     <p:sldMasterId id="2147483648" r:id="rId1"/>
   </p:sldMasterIdLst>
+  <p:notesMasterIdLst>
+    <p:notesMasterId r:id="rId28"/>
+  </p:notesMasterIdLst>
   <p:sldIdLst>
-    <p:sldId id="256" r:id="rId7"/>
-    <p:sldId id="257" r:id="rId8"/>
-    <p:sldId id="258" r:id="rId9"/>
-    <p:sldId id="259" r:id="rId10"/>
-    <p:sldId id="260" r:id="rId11"/>
-    <p:sldId id="261" r:id="rId12"/>
-    <p:sldId id="262" r:id="rId13"/>
-    <p:sldId id="263" r:id="rId14"/>
-    <p:sldId id="264" r:id="rId15"/>
-    <p:sldId id="265" r:id="rId16"/>
-    <p:sldId id="266" r:id="rId17"/>
-    <p:sldId id="267" r:id="rId18"/>
-    <p:sldId id="268" r:id="rId19"/>
-    <p:sldId id="269" r:id="rId20"/>
-    <p:sldId id="270" r:id="rId21"/>
-    <p:sldId id="271" r:id="rId22"/>
-    <p:sldId id="272" r:id="rId23"/>
-    <p:sldId id="273" r:id="rId24"/>
-    <p:sldId id="274" r:id="rId25"/>
-    <p:sldId id="275" r:id="rId26"/>
-    <p:sldId id="276" r:id="rId27"/>
-    <p:sldId id="277" r:id="rId28"/>
-    <p:sldId id="278" r:id="rId29"/>
-    <p:sldId id="279" r:id="rId30"/>
-    <p:sldId id="280" r:id="rId31"/>
-    <p:sldId id="281" r:id="rId32"/>
+    <p:sldId id="256" r:id="rId2"/>
+    <p:sldId id="257" r:id="rId3"/>
+    <p:sldId id="258" r:id="rId4"/>
+    <p:sldId id="259" r:id="rId5"/>
+    <p:sldId id="260" r:id="rId6"/>
+    <p:sldId id="261" r:id="rId7"/>
+    <p:sldId id="262" r:id="rId8"/>
+    <p:sldId id="263" r:id="rId9"/>
+    <p:sldId id="264" r:id="rId10"/>
+    <p:sldId id="265" r:id="rId11"/>
+    <p:sldId id="266" r:id="rId12"/>
+    <p:sldId id="267" r:id="rId13"/>
+    <p:sldId id="268" r:id="rId14"/>
+    <p:sldId id="269" r:id="rId15"/>
+    <p:sldId id="270" r:id="rId16"/>
+    <p:sldId id="271" r:id="rId17"/>
+    <p:sldId id="272" r:id="rId18"/>
+    <p:sldId id="273" r:id="rId19"/>
+    <p:sldId id="274" r:id="rId20"/>
+    <p:sldId id="275" r:id="rId21"/>
+    <p:sldId id="276" r:id="rId22"/>
+    <p:sldId id="277" r:id="rId23"/>
+    <p:sldId id="278" r:id="rId24"/>
+    <p:sldId id="279" r:id="rId25"/>
+    <p:sldId id="280" r:id="rId26"/>
+    <p:sldId id="281" r:id="rId27"/>
   </p:sldIdLst>
-  <p:sldSz cx="12191695" cy="6858000" type="screen4x3"/>
+  <p:sldSz cx="12192000" cy="6858000"/>
   <p:notesSz cx="6858000" cy="9144000"/>
   <p:defaultTextStyle>
     <a:defPPr>
@@ -129,7 +132,457 @@
       </a:defRPr>
     </a:lvl9pPr>
   </p:defaultTextStyle>
+  <p:extLst>
+    <p:ext uri="{EFAFB233-063F-42B5-8137-9DF3F51BA10A}">
+      <p15:sldGuideLst xmlns:p15="http://schemas.microsoft.com/office/powerpoint/2012/main">
+        <p15:guide id="1" orient="horz" pos="2160">
+          <p15:clr>
+            <a:srgbClr val="A4A3A4"/>
+          </p15:clr>
+        </p15:guide>
+        <p15:guide id="2" pos="2880">
+          <p15:clr>
+            <a:srgbClr val="A4A3A4"/>
+          </p15:clr>
+        </p15:guide>
+      </p15:sldGuideLst>
+    </p:ext>
+  </p:extLst>
 </p:presentation>
+</file>
+
+<file path=ppt/notesMasters/notesMaster1.xml><?xml version="1.0" encoding="utf-8"?>
+<p:notesMaster xmlns:a="http://schemas.openxmlformats.org/drawingml/2006/main" xmlns:r="http://schemas.openxmlformats.org/officeDocument/2006/relationships" xmlns:p="http://schemas.openxmlformats.org/presentationml/2006/main">
+  <p:cSld>
+    <p:bg>
+      <p:bgRef idx="1001">
+        <a:schemeClr val="bg1"/>
+      </p:bgRef>
+    </p:bg>
+    <p:spTree>
+      <p:nvGrpSpPr>
+        <p:cNvPr id="1" name=""/>
+        <p:cNvGrpSpPr/>
+        <p:nvPr/>
+      </p:nvGrpSpPr>
+      <p:grpSpPr>
+        <a:xfrm>
+          <a:off x="0" y="0"/>
+          <a:ext cx="0" cy="0"/>
+          <a:chOff x="0" y="0"/>
+          <a:chExt cx="0" cy="0"/>
+        </a:xfrm>
+      </p:grpSpPr>
+      <p:sp>
+        <p:nvSpPr>
+          <p:cNvPr id="2" name="Header Placeholder 1"/>
+          <p:cNvSpPr>
+            <a:spLocks noGrp="1"/>
+          </p:cNvSpPr>
+          <p:nvPr>
+            <p:ph type="hdr" sz="quarter"/>
+          </p:nvPr>
+        </p:nvSpPr>
+        <p:spPr>
+          <a:xfrm>
+            <a:off x="0" y="0"/>
+            <a:ext cx="2971800" cy="458788"/>
+          </a:xfrm>
+          <a:prstGeom prst="rect">
+            <a:avLst/>
+          </a:prstGeom>
+        </p:spPr>
+        <p:txBody>
+          <a:bodyPr vert="horz" lIns="91440" tIns="45720" rIns="91440" bIns="45720" rtlCol="0"/>
+          <a:lstStyle>
+            <a:lvl1pPr algn="l">
+              <a:defRPr sz="1200"/>
+            </a:lvl1pPr>
+          </a:lstStyle>
+          <a:p>
+            <a:endParaRPr lang="en-AU"/>
+          </a:p>
+        </p:txBody>
+      </p:sp>
+      <p:sp>
+        <p:nvSpPr>
+          <p:cNvPr id="3" name="Date Placeholder 2"/>
+          <p:cNvSpPr>
+            <a:spLocks noGrp="1"/>
+          </p:cNvSpPr>
+          <p:nvPr>
+            <p:ph type="dt" idx="1"/>
+          </p:nvPr>
+        </p:nvSpPr>
+        <p:spPr>
+          <a:xfrm>
+            <a:off x="3884613" y="0"/>
+            <a:ext cx="2971800" cy="458788"/>
+          </a:xfrm>
+          <a:prstGeom prst="rect">
+            <a:avLst/>
+          </a:prstGeom>
+        </p:spPr>
+        <p:txBody>
+          <a:bodyPr vert="horz" lIns="91440" tIns="45720" rIns="91440" bIns="45720" rtlCol="0"/>
+          <a:lstStyle>
+            <a:lvl1pPr algn="r">
+              <a:defRPr sz="1200"/>
+            </a:lvl1pPr>
+          </a:lstStyle>
+          <a:p>
+            <a:fld id="{9890B06A-6EBA-4AFC-94EE-11AF9381E625}" type="datetimeFigureOut">
+              <a:rPr lang="en-AU" smtClean="0"/>
+              <a:t>2/06/2026</a:t>
+            </a:fld>
+            <a:endParaRPr lang="en-AU"/>
+          </a:p>
+        </p:txBody>
+      </p:sp>
+      <p:sp>
+        <p:nvSpPr>
+          <p:cNvPr id="4" name="Slide Image Placeholder 3"/>
+          <p:cNvSpPr>
+            <a:spLocks noGrp="1" noRot="1" noChangeAspect="1"/>
+          </p:cNvSpPr>
+          <p:nvPr>
+            <p:ph type="sldImg" idx="2"/>
+          </p:nvPr>
+        </p:nvSpPr>
+        <p:spPr>
+          <a:xfrm>
+            <a:off x="685800" y="1143000"/>
+            <a:ext cx="5486400" cy="3086100"/>
+          </a:xfrm>
+          <a:prstGeom prst="rect">
+            <a:avLst/>
+          </a:prstGeom>
+          <a:noFill/>
+          <a:ln w="12700">
+            <a:solidFill>
+              <a:prstClr val="black"/>
+            </a:solidFill>
+          </a:ln>
+        </p:spPr>
+        <p:txBody>
+          <a:bodyPr vert="horz" lIns="91440" tIns="45720" rIns="91440" bIns="45720" rtlCol="0" anchor="ctr"/>
+          <a:lstStyle/>
+          <a:p>
+            <a:endParaRPr lang="en-AU"/>
+          </a:p>
+        </p:txBody>
+      </p:sp>
+      <p:sp>
+        <p:nvSpPr>
+          <p:cNvPr id="5" name="Notes Placeholder 4"/>
+          <p:cNvSpPr>
+            <a:spLocks noGrp="1"/>
+          </p:cNvSpPr>
+          <p:nvPr>
+            <p:ph type="body" sz="quarter" idx="3"/>
+          </p:nvPr>
+        </p:nvSpPr>
+        <p:spPr>
+          <a:xfrm>
+            <a:off x="685800" y="4400550"/>
+            <a:ext cx="5486400" cy="3600450"/>
+          </a:xfrm>
+          <a:prstGeom prst="rect">
+            <a:avLst/>
+          </a:prstGeom>
+        </p:spPr>
+        <p:txBody>
+          <a:bodyPr vert="horz" lIns="91440" tIns="45720" rIns="91440" bIns="45720" rtlCol="0"/>
+          <a:lstStyle/>
+          <a:p>
+            <a:pPr lvl="0"/>
+            <a:r>
+              <a:rPr lang="en-US"/>
+              <a:t>Click to edit Master text styles</a:t>
+            </a:r>
+          </a:p>
+          <a:p>
+            <a:pPr lvl="1"/>
+            <a:r>
+              <a:rPr lang="en-US"/>
+              <a:t>Second level</a:t>
+            </a:r>
+          </a:p>
+          <a:p>
+            <a:pPr lvl="2"/>
+            <a:r>
+              <a:rPr lang="en-US"/>
+              <a:t>Third level</a:t>
+            </a:r>
+          </a:p>
+          <a:p>
+            <a:pPr lvl="3"/>
+            <a:r>
+              <a:rPr lang="en-US"/>
+              <a:t>Fourth level</a:t>
+            </a:r>
+          </a:p>
+          <a:p>
+            <a:pPr lvl="4"/>
+            <a:r>
+              <a:rPr lang="en-US"/>
+              <a:t>Fifth level</a:t>
+            </a:r>
+            <a:endParaRPr lang="en-AU"/>
+          </a:p>
+        </p:txBody>
+      </p:sp>
+      <p:sp>
+        <p:nvSpPr>
+          <p:cNvPr id="6" name="Footer Placeholder 5"/>
+          <p:cNvSpPr>
+            <a:spLocks noGrp="1"/>
+          </p:cNvSpPr>
+          <p:nvPr>
+            <p:ph type="ftr" sz="quarter" idx="4"/>
+          </p:nvPr>
+        </p:nvSpPr>
+        <p:spPr>
+          <a:xfrm>
+            <a:off x="0" y="8685213"/>
+            <a:ext cx="2971800" cy="458787"/>
+          </a:xfrm>
+          <a:prstGeom prst="rect">
+            <a:avLst/>
+          </a:prstGeom>
+        </p:spPr>
+        <p:txBody>
+          <a:bodyPr vert="horz" lIns="91440" tIns="45720" rIns="91440" bIns="45720" rtlCol="0" anchor="b"/>
+          <a:lstStyle>
+            <a:lvl1pPr algn="l">
+              <a:defRPr sz="1200"/>
+            </a:lvl1pPr>
+          </a:lstStyle>
+          <a:p>
+            <a:endParaRPr lang="en-AU"/>
+          </a:p>
+        </p:txBody>
+      </p:sp>
+      <p:sp>
+        <p:nvSpPr>
+          <p:cNvPr id="7" name="Slide Number Placeholder 6"/>
+          <p:cNvSpPr>
+            <a:spLocks noGrp="1"/>
+          </p:cNvSpPr>
+          <p:nvPr>
+            <p:ph type="sldNum" sz="quarter" idx="5"/>
+          </p:nvPr>
+        </p:nvSpPr>
+        <p:spPr>
+          <a:xfrm>
+            <a:off x="3884613" y="8685213"/>
+            <a:ext cx="2971800" cy="458787"/>
+          </a:xfrm>
+          <a:prstGeom prst="rect">
+            <a:avLst/>
+          </a:prstGeom>
+        </p:spPr>
+        <p:txBody>
+          <a:bodyPr vert="horz" lIns="91440" tIns="45720" rIns="91440" bIns="45720" rtlCol="0" anchor="b"/>
+          <a:lstStyle>
+            <a:lvl1pPr algn="r">
+              <a:defRPr sz="1200"/>
+            </a:lvl1pPr>
+          </a:lstStyle>
+          <a:p>
+            <a:fld id="{1F743E08-7C00-4973-9AD1-14F753946BE0}" type="slidenum">
+              <a:rPr lang="en-AU" smtClean="0"/>
+              <a:t>‹#›</a:t>
+            </a:fld>
+            <a:endParaRPr lang="en-AU"/>
+          </a:p>
+        </p:txBody>
+      </p:sp>
+    </p:spTree>
+    <p:extLst>
+      <p:ext uri="{BB962C8B-B14F-4D97-AF65-F5344CB8AC3E}">
+        <p14:creationId xmlns:p14="http://schemas.microsoft.com/office/powerpoint/2010/main" val="3168934665"/>
+      </p:ext>
+    </p:extLst>
+  </p:cSld>
+  <p:clrMap bg1="lt1" tx1="dk1" bg2="lt2" tx2="dk2" accent1="accent1" accent2="accent2" accent3="accent3" accent4="accent4" accent5="accent5" accent6="accent6" hlink="hlink" folHlink="folHlink"/>
+  <p:notesStyle>
+    <a:lvl1pPr marL="0" algn="l" defTabSz="914400" rtl="0" eaLnBrk="1" latinLnBrk="0" hangingPunct="1">
+      <a:defRPr sz="1200" kern="1200">
+        <a:solidFill>
+          <a:schemeClr val="tx1"/>
+        </a:solidFill>
+        <a:latin typeface="+mn-lt"/>
+        <a:ea typeface="+mn-ea"/>
+        <a:cs typeface="+mn-cs"/>
+      </a:defRPr>
+    </a:lvl1pPr>
+    <a:lvl2pPr marL="457200" algn="l" defTabSz="914400" rtl="0" eaLnBrk="1" latinLnBrk="0" hangingPunct="1">
+      <a:defRPr sz="1200" kern="1200">
+        <a:solidFill>
+          <a:schemeClr val="tx1"/>
+        </a:solidFill>
+        <a:latin typeface="+mn-lt"/>
+        <a:ea typeface="+mn-ea"/>
+        <a:cs typeface="+mn-cs"/>
+      </a:defRPr>
+    </a:lvl2pPr>
+    <a:lvl3pPr marL="914400" algn="l" defTabSz="914400" rtl="0" eaLnBrk="1" latinLnBrk="0" hangingPunct="1">
+      <a:defRPr sz="1200" kern="1200">
+        <a:solidFill>
+          <a:schemeClr val="tx1"/>
+        </a:solidFill>
+        <a:latin typeface="+mn-lt"/>
+        <a:ea typeface="+mn-ea"/>
+        <a:cs typeface="+mn-cs"/>
+      </a:defRPr>
+    </a:lvl3pPr>
+    <a:lvl4pPr marL="1371600" algn="l" defTabSz="914400" rtl="0" eaLnBrk="1" latinLnBrk="0" hangingPunct="1">
+      <a:defRPr sz="1200" kern="1200">
+        <a:solidFill>
+          <a:schemeClr val="tx1"/>
+        </a:solidFill>
+        <a:latin typeface="+mn-lt"/>
+        <a:ea typeface="+mn-ea"/>
+        <a:cs typeface="+mn-cs"/>
+      </a:defRPr>
+    </a:lvl4pPr>
+    <a:lvl5pPr marL="1828800" algn="l" defTabSz="914400" rtl="0" eaLnBrk="1" latinLnBrk="0" hangingPunct="1">
+      <a:defRPr sz="1200" kern="1200">
+        <a:solidFill>
+          <a:schemeClr val="tx1"/>
+        </a:solidFill>
+        <a:latin typeface="+mn-lt"/>
+        <a:ea typeface="+mn-ea"/>
+        <a:cs typeface="+mn-cs"/>
+      </a:defRPr>
+    </a:lvl5pPr>
+    <a:lvl6pPr marL="2286000" algn="l" defTabSz="914400" rtl="0" eaLnBrk="1" latinLnBrk="0" hangingPunct="1">
+      <a:defRPr sz="1200" kern="1200">
+        <a:solidFill>
+          <a:schemeClr val="tx1"/>
+        </a:solidFill>
+        <a:latin typeface="+mn-lt"/>
+        <a:ea typeface="+mn-ea"/>
+        <a:cs typeface="+mn-cs"/>
+      </a:defRPr>
+    </a:lvl6pPr>
+    <a:lvl7pPr marL="2743200" algn="l" defTabSz="914400" rtl="0" eaLnBrk="1" latinLnBrk="0" hangingPunct="1">
+      <a:defRPr sz="1200" kern="1200">
+        <a:solidFill>
+          <a:schemeClr val="tx1"/>
+        </a:solidFill>
+        <a:latin typeface="+mn-lt"/>
+        <a:ea typeface="+mn-ea"/>
+        <a:cs typeface="+mn-cs"/>
+      </a:defRPr>
+    </a:lvl7pPr>
+    <a:lvl8pPr marL="3200400" algn="l" defTabSz="914400" rtl="0" eaLnBrk="1" latinLnBrk="0" hangingPunct="1">
+      <a:defRPr sz="1200" kern="1200">
+        <a:solidFill>
+          <a:schemeClr val="tx1"/>
+        </a:solidFill>
+        <a:latin typeface="+mn-lt"/>
+        <a:ea typeface="+mn-ea"/>
+        <a:cs typeface="+mn-cs"/>
+      </a:defRPr>
+    </a:lvl8pPr>
+    <a:lvl9pPr marL="3657600" algn="l" defTabSz="914400" rtl="0" eaLnBrk="1" latinLnBrk="0" hangingPunct="1">
+      <a:defRPr sz="1200" kern="1200">
+        <a:solidFill>
+          <a:schemeClr val="tx1"/>
+        </a:solidFill>
+        <a:latin typeface="+mn-lt"/>
+        <a:ea typeface="+mn-ea"/>
+        <a:cs typeface="+mn-cs"/>
+      </a:defRPr>
+    </a:lvl9pPr>
+  </p:notesStyle>
+</p:notesMaster>
+</file>
+
+<file path=ppt/notesSlides/notesSlide1.xml><?xml version="1.0" encoding="utf-8"?>
+<p:notes xmlns:a="http://schemas.openxmlformats.org/drawingml/2006/main" xmlns:r="http://schemas.openxmlformats.org/officeDocument/2006/relationships" xmlns:p="http://schemas.openxmlformats.org/presentationml/2006/main">
+  <p:cSld>
+    <p:spTree>
+      <p:nvGrpSpPr>
+        <p:cNvPr id="1" name=""/>
+        <p:cNvGrpSpPr/>
+        <p:nvPr/>
+      </p:nvGrpSpPr>
+      <p:grpSpPr>
+        <a:xfrm>
+          <a:off x="0" y="0"/>
+          <a:ext cx="0" cy="0"/>
+          <a:chOff x="0" y="0"/>
+          <a:chExt cx="0" cy="0"/>
+        </a:xfrm>
+      </p:grpSpPr>
+      <p:sp>
+        <p:nvSpPr>
+          <p:cNvPr id="2" name="Slide Image Placeholder 1"/>
+          <p:cNvSpPr>
+            <a:spLocks noGrp="1" noRot="1" noChangeAspect="1"/>
+          </p:cNvSpPr>
+          <p:nvPr>
+            <p:ph type="sldImg"/>
+          </p:nvPr>
+        </p:nvSpPr>
+        <p:spPr/>
+      </p:sp>
+      <p:sp>
+        <p:nvSpPr>
+          <p:cNvPr id="3" name="Notes Placeholder 2"/>
+          <p:cNvSpPr>
+            <a:spLocks noGrp="1"/>
+          </p:cNvSpPr>
+          <p:nvPr>
+            <p:ph type="body" idx="1"/>
+          </p:nvPr>
+        </p:nvSpPr>
+        <p:spPr/>
+        <p:txBody>
+          <a:bodyPr/>
+          <a:lstStyle/>
+          <a:p>
+            <a:endParaRPr lang="en-AU" dirty="0"/>
+          </a:p>
+        </p:txBody>
+      </p:sp>
+      <p:sp>
+        <p:nvSpPr>
+          <p:cNvPr id="4" name="Slide Number Placeholder 3"/>
+          <p:cNvSpPr>
+            <a:spLocks noGrp="1"/>
+          </p:cNvSpPr>
+          <p:nvPr>
+            <p:ph type="sldNum" sz="quarter" idx="5"/>
+          </p:nvPr>
+        </p:nvSpPr>
+        <p:spPr/>
+        <p:txBody>
+          <a:bodyPr/>
+          <a:lstStyle/>
+          <a:p>
+            <a:fld id="{1F743E08-7C00-4973-9AD1-14F753946BE0}" type="slidenum">
+              <a:rPr lang="en-AU" smtClean="0"/>
+              <a:t>15</a:t>
+            </a:fld>
+            <a:endParaRPr lang="en-AU"/>
+          </a:p>
+        </p:txBody>
+      </p:sp>
+    </p:spTree>
+    <p:extLst>
+      <p:ext uri="{BB962C8B-B14F-4D97-AF65-F5344CB8AC3E}">
+        <p14:creationId xmlns:p14="http://schemas.microsoft.com/office/powerpoint/2010/main" val="3999268144"/>
+      </p:ext>
+    </p:extLst>
+  </p:cSld>
+  <p:clrMapOvr>
+    <a:masterClrMapping/>
+  </p:clrMapOvr>
+</p:notes>
 </file>
 
 <file path=ppt/slideLayouts/slideLayout1.xml><?xml version="1.0" encoding="utf-8"?>
@@ -170,10 +623,9 @@
           <a:lstStyle/>
           <a:p>
             <a:r>
-              <a:rPr lang="en-US" smtClean="0"/>
+              <a:rPr lang="en-US"/>
               <a:t>Click to edit Master title style</a:t>
             </a:r>
-            <a:endParaRPr lang="en-US"/>
           </a:p>
         </p:txBody>
       </p:sp>
@@ -289,10 +741,9 @@
           </a:lstStyle>
           <a:p>
             <a:r>
-              <a:rPr lang="en-US" smtClean="0"/>
+              <a:rPr lang="en-US"/>
               <a:t>Click to edit Master subtitle style</a:t>
             </a:r>
-            <a:endParaRPr lang="en-US"/>
           </a:p>
         </p:txBody>
       </p:sp>
@@ -313,7 +764,7 @@
           <a:p>
             <a:fld id="{5BCAD085-E8A6-8845-BD4E-CB4CCA059FC4}" type="datetimeFigureOut">
               <a:rPr lang="en-US" smtClean="0"/>
-              <a:t>1/27/13</a:t>
+              <a:t>6/2/2026</a:t>
             </a:fld>
             <a:endParaRPr lang="en-US"/>
           </a:p>
@@ -407,10 +858,9 @@
           <a:lstStyle/>
           <a:p>
             <a:r>
-              <a:rPr lang="en-US" smtClean="0"/>
+              <a:rPr lang="en-US"/>
               <a:t>Click to edit Master title style</a:t>
             </a:r>
-            <a:endParaRPr lang="en-US"/>
           </a:p>
         </p:txBody>
       </p:sp>
@@ -431,38 +881,37 @@
           <a:p>
             <a:pPr lvl="0"/>
             <a:r>
-              <a:rPr lang="en-US" smtClean="0"/>
+              <a:rPr lang="en-US"/>
               <a:t>Click to edit Master text styles</a:t>
             </a:r>
           </a:p>
           <a:p>
             <a:pPr lvl="1"/>
             <a:r>
-              <a:rPr lang="en-US" smtClean="0"/>
+              <a:rPr lang="en-US"/>
               <a:t>Second level</a:t>
             </a:r>
           </a:p>
           <a:p>
             <a:pPr lvl="2"/>
             <a:r>
-              <a:rPr lang="en-US" smtClean="0"/>
+              <a:rPr lang="en-US"/>
               <a:t>Third level</a:t>
             </a:r>
           </a:p>
           <a:p>
             <a:pPr lvl="3"/>
             <a:r>
-              <a:rPr lang="en-US" smtClean="0"/>
+              <a:rPr lang="en-US"/>
               <a:t>Fourth level</a:t>
             </a:r>
           </a:p>
           <a:p>
             <a:pPr lvl="4"/>
             <a:r>
-              <a:rPr lang="en-US" smtClean="0"/>
+              <a:rPr lang="en-US"/>
               <a:t>Fifth level</a:t>
             </a:r>
-            <a:endParaRPr lang="en-US"/>
           </a:p>
         </p:txBody>
       </p:sp>
@@ -483,7 +932,7 @@
           <a:p>
             <a:fld id="{5BCAD085-E8A6-8845-BD4E-CB4CCA059FC4}" type="datetimeFigureOut">
               <a:rPr lang="en-US" smtClean="0"/>
-              <a:t>1/27/13</a:t>
+              <a:t>6/2/2026</a:t>
             </a:fld>
             <a:endParaRPr lang="en-US"/>
           </a:p>
@@ -582,10 +1031,9 @@
           <a:lstStyle/>
           <a:p>
             <a:r>
-              <a:rPr lang="en-US" smtClean="0"/>
+              <a:rPr lang="en-US"/>
               <a:t>Click to edit Master title style</a:t>
             </a:r>
-            <a:endParaRPr lang="en-US"/>
           </a:p>
         </p:txBody>
       </p:sp>
@@ -611,38 +1059,37 @@
           <a:p>
             <a:pPr lvl="0"/>
             <a:r>
-              <a:rPr lang="en-US" smtClean="0"/>
+              <a:rPr lang="en-US"/>
               <a:t>Click to edit Master text styles</a:t>
             </a:r>
           </a:p>
           <a:p>
             <a:pPr lvl="1"/>
             <a:r>
-              <a:rPr lang="en-US" smtClean="0"/>
+              <a:rPr lang="en-US"/>
               <a:t>Second level</a:t>
             </a:r>
           </a:p>
           <a:p>
             <a:pPr lvl="2"/>
             <a:r>
-              <a:rPr lang="en-US" smtClean="0"/>
+              <a:rPr lang="en-US"/>
               <a:t>Third level</a:t>
             </a:r>
           </a:p>
           <a:p>
             <a:pPr lvl="3"/>
             <a:r>
-              <a:rPr lang="en-US" smtClean="0"/>
+              <a:rPr lang="en-US"/>
               <a:t>Fourth level</a:t>
             </a:r>
           </a:p>
           <a:p>
             <a:pPr lvl="4"/>
             <a:r>
-              <a:rPr lang="en-US" smtClean="0"/>
+              <a:rPr lang="en-US"/>
               <a:t>Fifth level</a:t>
             </a:r>
-            <a:endParaRPr lang="en-US"/>
           </a:p>
         </p:txBody>
       </p:sp>
@@ -663,7 +1110,7 @@
           <a:p>
             <a:fld id="{5BCAD085-E8A6-8845-BD4E-CB4CCA059FC4}" type="datetimeFigureOut">
               <a:rPr lang="en-US" smtClean="0"/>
-              <a:t>1/27/13</a:t>
+              <a:t>6/2/2026</a:t>
             </a:fld>
             <a:endParaRPr lang="en-US"/>
           </a:p>
@@ -757,10 +1204,9 @@
           <a:lstStyle/>
           <a:p>
             <a:r>
-              <a:rPr lang="en-US" smtClean="0"/>
+              <a:rPr lang="en-US"/>
               <a:t>Click to edit Master title style</a:t>
             </a:r>
-            <a:endParaRPr lang="en-US"/>
           </a:p>
         </p:txBody>
       </p:sp>
@@ -781,38 +1227,37 @@
           <a:p>
             <a:pPr lvl="0"/>
             <a:r>
-              <a:rPr lang="en-US" smtClean="0"/>
+              <a:rPr lang="en-US"/>
               <a:t>Click to edit Master text styles</a:t>
             </a:r>
           </a:p>
           <a:p>
             <a:pPr lvl="1"/>
             <a:r>
-              <a:rPr lang="en-US" smtClean="0"/>
+              <a:rPr lang="en-US"/>
               <a:t>Second level</a:t>
             </a:r>
           </a:p>
           <a:p>
             <a:pPr lvl="2"/>
             <a:r>
-              <a:rPr lang="en-US" smtClean="0"/>
+              <a:rPr lang="en-US"/>
               <a:t>Third level</a:t>
             </a:r>
           </a:p>
           <a:p>
             <a:pPr lvl="3"/>
             <a:r>
-              <a:rPr lang="en-US" smtClean="0"/>
+              <a:rPr lang="en-US"/>
               <a:t>Fourth level</a:t>
             </a:r>
           </a:p>
           <a:p>
             <a:pPr lvl="4"/>
             <a:r>
-              <a:rPr lang="en-US" smtClean="0"/>
+              <a:rPr lang="en-US"/>
               <a:t>Fifth level</a:t>
             </a:r>
-            <a:endParaRPr lang="en-US"/>
           </a:p>
         </p:txBody>
       </p:sp>
@@ -833,7 +1278,7 @@
           <a:p>
             <a:fld id="{5BCAD085-E8A6-8845-BD4E-CB4CCA059FC4}" type="datetimeFigureOut">
               <a:rPr lang="en-US" smtClean="0"/>
-              <a:t>1/27/13</a:t>
+              <a:t>6/2/2026</a:t>
             </a:fld>
             <a:endParaRPr lang="en-US"/>
           </a:p>
@@ -936,10 +1381,9 @@
           </a:lstStyle>
           <a:p>
             <a:r>
-              <a:rPr lang="en-US" smtClean="0"/>
+              <a:rPr lang="en-US"/>
               <a:t>Click to edit Master title style</a:t>
             </a:r>
-            <a:endParaRPr lang="en-US"/>
           </a:p>
         </p:txBody>
       </p:sp>
@@ -1056,7 +1500,7 @@
           <a:p>
             <a:pPr lvl="0"/>
             <a:r>
-              <a:rPr lang="en-US" smtClean="0"/>
+              <a:rPr lang="en-US"/>
               <a:t>Click to edit Master text styles</a:t>
             </a:r>
           </a:p>
@@ -1079,7 +1523,7 @@
           <a:p>
             <a:fld id="{5BCAD085-E8A6-8845-BD4E-CB4CCA059FC4}" type="datetimeFigureOut">
               <a:rPr lang="en-US" smtClean="0"/>
-              <a:t>1/27/13</a:t>
+              <a:t>6/2/2026</a:t>
             </a:fld>
             <a:endParaRPr lang="en-US"/>
           </a:p>
@@ -1173,10 +1617,9 @@
           <a:lstStyle/>
           <a:p>
             <a:r>
-              <a:rPr lang="en-US" smtClean="0"/>
+              <a:rPr lang="en-US"/>
               <a:t>Click to edit Master title style</a:t>
             </a:r>
-            <a:endParaRPr lang="en-US"/>
           </a:p>
         </p:txBody>
       </p:sp>
@@ -1230,38 +1673,37 @@
           <a:p>
             <a:pPr lvl="0"/>
             <a:r>
-              <a:rPr lang="en-US" smtClean="0"/>
+              <a:rPr lang="en-US"/>
               <a:t>Click to edit Master text styles</a:t>
             </a:r>
           </a:p>
           <a:p>
             <a:pPr lvl="1"/>
             <a:r>
-              <a:rPr lang="en-US" smtClean="0"/>
+              <a:rPr lang="en-US"/>
               <a:t>Second level</a:t>
             </a:r>
           </a:p>
           <a:p>
             <a:pPr lvl="2"/>
             <a:r>
-              <a:rPr lang="en-US" smtClean="0"/>
+              <a:rPr lang="en-US"/>
               <a:t>Third level</a:t>
             </a:r>
           </a:p>
           <a:p>
             <a:pPr lvl="3"/>
             <a:r>
-              <a:rPr lang="en-US" smtClean="0"/>
+              <a:rPr lang="en-US"/>
               <a:t>Fourth level</a:t>
             </a:r>
           </a:p>
           <a:p>
             <a:pPr lvl="4"/>
             <a:r>
-              <a:rPr lang="en-US" smtClean="0"/>
+              <a:rPr lang="en-US"/>
               <a:t>Fifth level</a:t>
             </a:r>
-            <a:endParaRPr lang="en-US"/>
           </a:p>
         </p:txBody>
       </p:sp>
@@ -1315,38 +1757,37 @@
           <a:p>
             <a:pPr lvl="0"/>
             <a:r>
-              <a:rPr lang="en-US" smtClean="0"/>
+              <a:rPr lang="en-US"/>
               <a:t>Click to edit Master text styles</a:t>
             </a:r>
           </a:p>
           <a:p>
             <a:pPr lvl="1"/>
             <a:r>
-              <a:rPr lang="en-US" smtClean="0"/>
+              <a:rPr lang="en-US"/>
               <a:t>Second level</a:t>
             </a:r>
           </a:p>
           <a:p>
             <a:pPr lvl="2"/>
             <a:r>
-              <a:rPr lang="en-US" smtClean="0"/>
+              <a:rPr lang="en-US"/>
               <a:t>Third level</a:t>
             </a:r>
           </a:p>
           <a:p>
             <a:pPr lvl="3"/>
             <a:r>
-              <a:rPr lang="en-US" smtClean="0"/>
+              <a:rPr lang="en-US"/>
               <a:t>Fourth level</a:t>
             </a:r>
           </a:p>
           <a:p>
             <a:pPr lvl="4"/>
             <a:r>
-              <a:rPr lang="en-US" smtClean="0"/>
+              <a:rPr lang="en-US"/>
               <a:t>Fifth level</a:t>
             </a:r>
-            <a:endParaRPr lang="en-US"/>
           </a:p>
         </p:txBody>
       </p:sp>
@@ -1367,7 +1808,7 @@
           <a:p>
             <a:fld id="{5BCAD085-E8A6-8845-BD4E-CB4CCA059FC4}" type="datetimeFigureOut">
               <a:rPr lang="en-US" smtClean="0"/>
-              <a:t>1/27/13</a:t>
+              <a:t>6/2/2026</a:t>
             </a:fld>
             <a:endParaRPr lang="en-US"/>
           </a:p>
@@ -1465,10 +1906,9 @@
           </a:lstStyle>
           <a:p>
             <a:r>
-              <a:rPr lang="en-US" smtClean="0"/>
+              <a:rPr lang="en-US"/>
               <a:t>Click to edit Master title style</a:t>
             </a:r>
-            <a:endParaRPr lang="en-US"/>
           </a:p>
         </p:txBody>
       </p:sp>
@@ -1531,7 +1971,7 @@
           <a:p>
             <a:pPr lvl="0"/>
             <a:r>
-              <a:rPr lang="en-US" smtClean="0"/>
+              <a:rPr lang="en-US"/>
               <a:t>Click to edit Master text styles</a:t>
             </a:r>
           </a:p>
@@ -1587,38 +2027,37 @@
           <a:p>
             <a:pPr lvl="0"/>
             <a:r>
-              <a:rPr lang="en-US" smtClean="0"/>
+              <a:rPr lang="en-US"/>
               <a:t>Click to edit Master text styles</a:t>
             </a:r>
           </a:p>
           <a:p>
             <a:pPr lvl="1"/>
             <a:r>
-              <a:rPr lang="en-US" smtClean="0"/>
+              <a:rPr lang="en-US"/>
               <a:t>Second level</a:t>
             </a:r>
           </a:p>
           <a:p>
             <a:pPr lvl="2"/>
             <a:r>
-              <a:rPr lang="en-US" smtClean="0"/>
+              <a:rPr lang="en-US"/>
               <a:t>Third level</a:t>
             </a:r>
           </a:p>
           <a:p>
             <a:pPr lvl="3"/>
             <a:r>
-              <a:rPr lang="en-US" smtClean="0"/>
+              <a:rPr lang="en-US"/>
               <a:t>Fourth level</a:t>
             </a:r>
           </a:p>
           <a:p>
             <a:pPr lvl="4"/>
             <a:r>
-              <a:rPr lang="en-US" smtClean="0"/>
+              <a:rPr lang="en-US"/>
               <a:t>Fifth level</a:t>
             </a:r>
-            <a:endParaRPr lang="en-US"/>
           </a:p>
         </p:txBody>
       </p:sp>
@@ -1681,7 +2120,7 @@
           <a:p>
             <a:pPr lvl="0"/>
             <a:r>
-              <a:rPr lang="en-US" smtClean="0"/>
+              <a:rPr lang="en-US"/>
               <a:t>Click to edit Master text styles</a:t>
             </a:r>
           </a:p>
@@ -1737,38 +2176,37 @@
           <a:p>
             <a:pPr lvl="0"/>
             <a:r>
-              <a:rPr lang="en-US" smtClean="0"/>
+              <a:rPr lang="en-US"/>
               <a:t>Click to edit Master text styles</a:t>
             </a:r>
           </a:p>
           <a:p>
             <a:pPr lvl="1"/>
             <a:r>
-              <a:rPr lang="en-US" smtClean="0"/>
+              <a:rPr lang="en-US"/>
               <a:t>Second level</a:t>
             </a:r>
           </a:p>
           <a:p>
             <a:pPr lvl="2"/>
             <a:r>
-              <a:rPr lang="en-US" smtClean="0"/>
+              <a:rPr lang="en-US"/>
               <a:t>Third level</a:t>
             </a:r>
           </a:p>
           <a:p>
             <a:pPr lvl="3"/>
             <a:r>
-              <a:rPr lang="en-US" smtClean="0"/>
+              <a:rPr lang="en-US"/>
               <a:t>Fourth level</a:t>
             </a:r>
           </a:p>
           <a:p>
             <a:pPr lvl="4"/>
             <a:r>
-              <a:rPr lang="en-US" smtClean="0"/>
+              <a:rPr lang="en-US"/>
               <a:t>Fifth level</a:t>
             </a:r>
-            <a:endParaRPr lang="en-US"/>
           </a:p>
         </p:txBody>
       </p:sp>
@@ -1789,7 +2227,7 @@
           <a:p>
             <a:fld id="{5BCAD085-E8A6-8845-BD4E-CB4CCA059FC4}" type="datetimeFigureOut">
               <a:rPr lang="en-US" smtClean="0"/>
-              <a:t>1/27/13</a:t>
+              <a:t>6/2/2026</a:t>
             </a:fld>
             <a:endParaRPr lang="en-US"/>
           </a:p>
@@ -1883,10 +2321,9 @@
           <a:lstStyle/>
           <a:p>
             <a:r>
-              <a:rPr lang="en-US" smtClean="0"/>
+              <a:rPr lang="en-US"/>
               <a:t>Click to edit Master title style</a:t>
             </a:r>
-            <a:endParaRPr lang="en-US"/>
           </a:p>
         </p:txBody>
       </p:sp>
@@ -1907,7 +2344,7 @@
           <a:p>
             <a:fld id="{5BCAD085-E8A6-8845-BD4E-CB4CCA059FC4}" type="datetimeFigureOut">
               <a:rPr lang="en-US" smtClean="0"/>
-              <a:t>1/27/13</a:t>
+              <a:t>6/2/2026</a:t>
             </a:fld>
             <a:endParaRPr lang="en-US"/>
           </a:p>
@@ -2002,7 +2439,7 @@
           <a:p>
             <a:fld id="{5BCAD085-E8A6-8845-BD4E-CB4CCA059FC4}" type="datetimeFigureOut">
               <a:rPr lang="en-US" smtClean="0"/>
-              <a:t>1/27/13</a:t>
+              <a:t>6/2/2026</a:t>
             </a:fld>
             <a:endParaRPr lang="en-US"/>
           </a:p>
@@ -2105,10 +2542,9 @@
           </a:lstStyle>
           <a:p>
             <a:r>
-              <a:rPr lang="en-US" smtClean="0"/>
+              <a:rPr lang="en-US"/>
               <a:t>Click to edit Master title style</a:t>
             </a:r>
-            <a:endParaRPr lang="en-US"/>
           </a:p>
         </p:txBody>
       </p:sp>
@@ -2162,38 +2598,37 @@
           <a:p>
             <a:pPr lvl="0"/>
             <a:r>
-              <a:rPr lang="en-US" smtClean="0"/>
+              <a:rPr lang="en-US"/>
               <a:t>Click to edit Master text styles</a:t>
             </a:r>
           </a:p>
           <a:p>
             <a:pPr lvl="1"/>
             <a:r>
-              <a:rPr lang="en-US" smtClean="0"/>
+              <a:rPr lang="en-US"/>
               <a:t>Second level</a:t>
             </a:r>
           </a:p>
           <a:p>
             <a:pPr lvl="2"/>
             <a:r>
-              <a:rPr lang="en-US" smtClean="0"/>
+              <a:rPr lang="en-US"/>
               <a:t>Third level</a:t>
             </a:r>
           </a:p>
           <a:p>
             <a:pPr lvl="3"/>
             <a:r>
-              <a:rPr lang="en-US" smtClean="0"/>
+              <a:rPr lang="en-US"/>
               <a:t>Fourth level</a:t>
             </a:r>
           </a:p>
           <a:p>
             <a:pPr lvl="4"/>
             <a:r>
-              <a:rPr lang="en-US" smtClean="0"/>
+              <a:rPr lang="en-US"/>
               <a:t>Fifth level</a:t>
             </a:r>
-            <a:endParaRPr lang="en-US"/>
           </a:p>
         </p:txBody>
       </p:sp>
@@ -2256,7 +2691,7 @@
           <a:p>
             <a:pPr lvl="0"/>
             <a:r>
-              <a:rPr lang="en-US" smtClean="0"/>
+              <a:rPr lang="en-US"/>
               <a:t>Click to edit Master text styles</a:t>
             </a:r>
           </a:p>
@@ -2279,7 +2714,7 @@
           <a:p>
             <a:fld id="{5BCAD085-E8A6-8845-BD4E-CB4CCA059FC4}" type="datetimeFigureOut">
               <a:rPr lang="en-US" smtClean="0"/>
-              <a:t>1/27/13</a:t>
+              <a:t>6/2/2026</a:t>
             </a:fld>
             <a:endParaRPr lang="en-US"/>
           </a:p>
@@ -2382,10 +2817,9 @@
           </a:lstStyle>
           <a:p>
             <a:r>
-              <a:rPr lang="en-US" smtClean="0"/>
+              <a:rPr lang="en-US"/>
               <a:t>Click to edit Master title style</a:t>
             </a:r>
-            <a:endParaRPr lang="en-US"/>
           </a:p>
         </p:txBody>
       </p:sp>
@@ -2509,7 +2943,7 @@
           <a:p>
             <a:pPr lvl="0"/>
             <a:r>
-              <a:rPr lang="en-US" smtClean="0"/>
+              <a:rPr lang="en-US"/>
               <a:t>Click to edit Master text styles</a:t>
             </a:r>
           </a:p>
@@ -2532,7 +2966,7 @@
           <a:p>
             <a:fld id="{5BCAD085-E8A6-8845-BD4E-CB4CCA059FC4}" type="datetimeFigureOut">
               <a:rPr lang="en-US" smtClean="0"/>
-              <a:t>1/27/13</a:t>
+              <a:t>6/2/2026</a:t>
             </a:fld>
             <a:endParaRPr lang="en-US"/>
           </a:p>
@@ -2641,10 +3075,9 @@
           <a:lstStyle/>
           <a:p>
             <a:r>
-              <a:rPr lang="en-US" smtClean="0"/>
+              <a:rPr lang="en-US"/>
               <a:t>Click to edit Master title style</a:t>
             </a:r>
-            <a:endParaRPr lang="en-US"/>
           </a:p>
         </p:txBody>
       </p:sp>
@@ -2675,38 +3108,37 @@
           <a:p>
             <a:pPr lvl="0"/>
             <a:r>
-              <a:rPr lang="en-US" smtClean="0"/>
+              <a:rPr lang="en-US"/>
               <a:t>Click to edit Master text styles</a:t>
             </a:r>
           </a:p>
           <a:p>
             <a:pPr lvl="1"/>
             <a:r>
-              <a:rPr lang="en-US" smtClean="0"/>
+              <a:rPr lang="en-US"/>
               <a:t>Second level</a:t>
             </a:r>
           </a:p>
           <a:p>
             <a:pPr lvl="2"/>
             <a:r>
-              <a:rPr lang="en-US" smtClean="0"/>
+              <a:rPr lang="en-US"/>
               <a:t>Third level</a:t>
             </a:r>
           </a:p>
           <a:p>
             <a:pPr lvl="3"/>
             <a:r>
-              <a:rPr lang="en-US" smtClean="0"/>
+              <a:rPr lang="en-US"/>
               <a:t>Fourth level</a:t>
             </a:r>
           </a:p>
           <a:p>
             <a:pPr lvl="4"/>
             <a:r>
-              <a:rPr lang="en-US" smtClean="0"/>
+              <a:rPr lang="en-US"/>
               <a:t>Fifth level</a:t>
             </a:r>
-            <a:endParaRPr lang="en-US"/>
           </a:p>
         </p:txBody>
       </p:sp>
@@ -2745,7 +3177,7 @@
           <a:p>
             <a:fld id="{5BCAD085-E8A6-8845-BD4E-CB4CCA059FC4}" type="datetimeFigureOut">
               <a:rPr lang="en-US" smtClean="0"/>
-              <a:t>1/27/13</a:t>
+              <a:t>6/2/2026</a:t>
             </a:fld>
             <a:endParaRPr lang="en-US"/>
           </a:p>
@@ -3104,7 +3536,7 @@
 </file>
 
 <file path=ppt/slides/slide1.xml><?xml version="1.0" encoding="utf-8"?>
-<p:sld xmlns:a="http://schemas.openxmlformats.org/drawingml/2006/main" xmlns:p="http://schemas.openxmlformats.org/presentationml/2006/main" xmlns:r="http://schemas.openxmlformats.org/officeDocument/2006/relationships">
+<p:sld xmlns:a="http://schemas.openxmlformats.org/drawingml/2006/main" xmlns:r="http://schemas.openxmlformats.org/officeDocument/2006/relationships" xmlns:p="http://schemas.openxmlformats.org/presentationml/2006/main">
   <p:cSld>
     <p:bg>
       <p:bgPr>
@@ -3120,7 +3552,14 @@
         <p:cNvGrpSpPr/>
         <p:nvPr/>
       </p:nvGrpSpPr>
-      <p:grpSpPr/>
+      <p:grpSpPr>
+        <a:xfrm>
+          <a:off x="0" y="0"/>
+          <a:ext cx="0" cy="0"/>
+          <a:chOff x="0" y="0"/>
+          <a:chExt cx="0" cy="0"/>
+        </a:xfrm>
+      </p:grpSpPr>
       <p:sp>
         <p:nvSpPr>
           <p:cNvPr id="2" name="Rectangle 1"/>
@@ -3162,6 +3601,7 @@
           <a:lstStyle/>
           <a:p>
             <a:pPr algn="ctr"/>
+            <a:endParaRPr/>
           </a:p>
         </p:txBody>
       </p:sp>
@@ -3182,7 +3622,7 @@
           <a:noFill/>
         </p:spPr>
         <p:txBody>
-          <a:bodyPr wrap="square" anchor="t" lIns="0" rIns="0" tIns="0" bIns="0">
+          <a:bodyPr wrap="square" lIns="0" tIns="0" rIns="0" bIns="0" anchor="t">
             <a:spAutoFit/>
           </a:bodyPr>
           <a:lstStyle/>
@@ -3248,7 +3688,7 @@
           <a:noFill/>
         </p:spPr>
         <p:txBody>
-          <a:bodyPr wrap="square" anchor="t" lIns="0" rIns="0" tIns="0" bIns="0">
+          <a:bodyPr wrap="square" lIns="0" tIns="0" rIns="0" bIns="0" anchor="t">
             <a:spAutoFit/>
           </a:bodyPr>
           <a:lstStyle/>
@@ -3283,7 +3723,7 @@
 </file>
 
 <file path=ppt/slides/slide10.xml><?xml version="1.0" encoding="utf-8"?>
-<p:sld xmlns:a="http://schemas.openxmlformats.org/drawingml/2006/main" xmlns:p="http://schemas.openxmlformats.org/presentationml/2006/main" xmlns:r="http://schemas.openxmlformats.org/officeDocument/2006/relationships">
+<p:sld xmlns:a="http://schemas.openxmlformats.org/drawingml/2006/main" xmlns:r="http://schemas.openxmlformats.org/officeDocument/2006/relationships" xmlns:p="http://schemas.openxmlformats.org/presentationml/2006/main">
   <p:cSld>
     <p:bg>
       <p:bgPr>
@@ -3299,7 +3739,14 @@
         <p:cNvGrpSpPr/>
         <p:nvPr/>
       </p:nvGrpSpPr>
-      <p:grpSpPr/>
+      <p:grpSpPr>
+        <a:xfrm>
+          <a:off x="0" y="0"/>
+          <a:ext cx="0" cy="0"/>
+          <a:chOff x="0" y="0"/>
+          <a:chExt cx="0" cy="0"/>
+        </a:xfrm>
+      </p:grpSpPr>
       <p:sp>
         <p:nvSpPr>
           <p:cNvPr id="2" name="TextBox 1"/>
@@ -3317,7 +3764,7 @@
           <a:noFill/>
         </p:spPr>
         <p:txBody>
-          <a:bodyPr wrap="square" anchor="t" lIns="0" rIns="0" tIns="0" bIns="0">
+          <a:bodyPr wrap="square" lIns="0" tIns="0" rIns="0" bIns="0" anchor="t">
             <a:spAutoFit/>
           </a:bodyPr>
           <a:lstStyle/>
@@ -3391,6 +3838,7 @@
           <a:lstStyle/>
           <a:p>
             <a:pPr algn="ctr"/>
+            <a:endParaRPr/>
           </a:p>
         </p:txBody>
       </p:sp>
@@ -3437,6 +3885,7 @@
           <a:lstStyle/>
           <a:p>
             <a:pPr algn="ctr"/>
+            <a:endParaRPr/>
           </a:p>
         </p:txBody>
       </p:sp>
@@ -3481,6 +3930,7 @@
           <a:lstStyle/>
           <a:p>
             <a:pPr algn="ctr"/>
+            <a:endParaRPr/>
           </a:p>
         </p:txBody>
       </p:sp>
@@ -3501,7 +3951,7 @@
           <a:noFill/>
         </p:spPr>
         <p:txBody>
-          <a:bodyPr wrap="square" anchor="ctr" lIns="0" rIns="0" tIns="0" bIns="0">
+          <a:bodyPr wrap="square" lIns="0" tIns="0" rIns="0" bIns="0" anchor="ctr">
             <a:spAutoFit/>
           </a:bodyPr>
           <a:lstStyle/>
@@ -3566,6 +4016,7 @@
           <a:lstStyle/>
           <a:p>
             <a:pPr algn="ctr"/>
+            <a:endParaRPr/>
           </a:p>
         </p:txBody>
       </p:sp>
@@ -3610,6 +4061,7 @@
           <a:lstStyle/>
           <a:p>
             <a:pPr algn="ctr"/>
+            <a:endParaRPr/>
           </a:p>
         </p:txBody>
       </p:sp>
@@ -3630,7 +4082,7 @@
           <a:noFill/>
         </p:spPr>
         <p:txBody>
-          <a:bodyPr wrap="square" anchor="ctr" lIns="0" rIns="0" tIns="0" bIns="0">
+          <a:bodyPr wrap="square" lIns="0" tIns="0" rIns="0" bIns="0" anchor="ctr">
             <a:spAutoFit/>
           </a:bodyPr>
           <a:lstStyle/>
@@ -3695,6 +4147,7 @@
           <a:lstStyle/>
           <a:p>
             <a:pPr algn="ctr"/>
+            <a:endParaRPr/>
           </a:p>
         </p:txBody>
       </p:sp>
@@ -3739,6 +4192,7 @@
           <a:lstStyle/>
           <a:p>
             <a:pPr algn="ctr"/>
+            <a:endParaRPr/>
           </a:p>
         </p:txBody>
       </p:sp>
@@ -3759,7 +4213,7 @@
           <a:noFill/>
         </p:spPr>
         <p:txBody>
-          <a:bodyPr wrap="square" anchor="ctr" lIns="0" rIns="0" tIns="0" bIns="0">
+          <a:bodyPr wrap="square" lIns="0" tIns="0" rIns="0" bIns="0" anchor="ctr">
             <a:spAutoFit/>
           </a:bodyPr>
           <a:lstStyle/>
@@ -3824,6 +4278,7 @@
           <a:lstStyle/>
           <a:p>
             <a:pPr algn="ctr"/>
+            <a:endParaRPr/>
           </a:p>
         </p:txBody>
       </p:sp>
@@ -3868,6 +4323,7 @@
           <a:lstStyle/>
           <a:p>
             <a:pPr algn="ctr"/>
+            <a:endParaRPr/>
           </a:p>
         </p:txBody>
       </p:sp>
@@ -3888,7 +4344,7 @@
           <a:noFill/>
         </p:spPr>
         <p:txBody>
-          <a:bodyPr wrap="square" anchor="ctr" lIns="0" rIns="0" tIns="0" bIns="0">
+          <a:bodyPr wrap="square" lIns="0" tIns="0" rIns="0" bIns="0" anchor="ctr">
             <a:spAutoFit/>
           </a:bodyPr>
           <a:lstStyle/>
@@ -3951,6 +4407,7 @@
           <a:lstStyle/>
           <a:p>
             <a:pPr algn="ctr"/>
+            <a:endParaRPr/>
           </a:p>
         </p:txBody>
       </p:sp>
@@ -3971,7 +4428,7 @@
           <a:noFill/>
         </p:spPr>
         <p:txBody>
-          <a:bodyPr wrap="square" anchor="t" lIns="0" rIns="0" tIns="0" bIns="0">
+          <a:bodyPr wrap="square" lIns="0" tIns="0" rIns="0" bIns="0" anchor="t">
             <a:spAutoFit/>
           </a:bodyPr>
           <a:lstStyle/>
@@ -4014,7 +4471,7 @@
           <a:noFill/>
         </p:spPr>
         <p:txBody>
-          <a:bodyPr wrap="square" anchor="t" lIns="0" rIns="0" tIns="0" bIns="0">
+          <a:bodyPr wrap="square" lIns="0" tIns="0" rIns="0" bIns="0" anchor="t">
             <a:spAutoFit/>
           </a:bodyPr>
           <a:lstStyle/>
@@ -4041,7 +4498,7 @@
 </file>
 
 <file path=ppt/slides/slide11.xml><?xml version="1.0" encoding="utf-8"?>
-<p:sld xmlns:a="http://schemas.openxmlformats.org/drawingml/2006/main" xmlns:p="http://schemas.openxmlformats.org/presentationml/2006/main" xmlns:r="http://schemas.openxmlformats.org/officeDocument/2006/relationships">
+<p:sld xmlns:a="http://schemas.openxmlformats.org/drawingml/2006/main" xmlns:r="http://schemas.openxmlformats.org/officeDocument/2006/relationships" xmlns:p="http://schemas.openxmlformats.org/presentationml/2006/main">
   <p:cSld>
     <p:bg>
       <p:bgPr>
@@ -4057,7 +4514,14 @@
         <p:cNvGrpSpPr/>
         <p:nvPr/>
       </p:nvGrpSpPr>
-      <p:grpSpPr/>
+      <p:grpSpPr>
+        <a:xfrm>
+          <a:off x="0" y="0"/>
+          <a:ext cx="0" cy="0"/>
+          <a:chOff x="0" y="0"/>
+          <a:chExt cx="0" cy="0"/>
+        </a:xfrm>
+      </p:grpSpPr>
       <p:sp>
         <p:nvSpPr>
           <p:cNvPr id="2" name="Rectangle 1"/>
@@ -4099,6 +4563,7 @@
           <a:lstStyle/>
           <a:p>
             <a:pPr algn="ctr"/>
+            <a:endParaRPr/>
           </a:p>
         </p:txBody>
       </p:sp>
@@ -4119,7 +4584,7 @@
           <a:noFill/>
         </p:spPr>
         <p:txBody>
-          <a:bodyPr wrap="square" anchor="t" lIns="0" rIns="0" tIns="0" bIns="0">
+          <a:bodyPr wrap="square" lIns="0" tIns="0" rIns="0" bIns="0" anchor="t">
             <a:spAutoFit/>
           </a:bodyPr>
           <a:lstStyle/>
@@ -4153,7 +4618,7 @@
           <a:noFill/>
         </p:spPr>
         <p:txBody>
-          <a:bodyPr wrap="square" anchor="t" lIns="0" rIns="0" tIns="0" bIns="0">
+          <a:bodyPr wrap="square" lIns="0" tIns="0" rIns="0" bIns="0" anchor="t">
             <a:spAutoFit/>
           </a:bodyPr>
           <a:lstStyle/>
@@ -4243,6 +4708,7 @@
           <a:lstStyle/>
           <a:p>
             <a:pPr algn="ctr"/>
+            <a:endParaRPr/>
           </a:p>
         </p:txBody>
       </p:sp>
@@ -4263,7 +4729,7 @@
           <a:noFill/>
         </p:spPr>
         <p:txBody>
-          <a:bodyPr wrap="square" anchor="t" lIns="0" rIns="0" tIns="0" bIns="0">
+          <a:bodyPr wrap="square" lIns="0" tIns="0" rIns="0" bIns="0" anchor="t">
             <a:spAutoFit/>
           </a:bodyPr>
           <a:lstStyle/>
@@ -4306,21 +4772,13 @@
           <a:noFill/>
         </p:spPr>
         <p:txBody>
-          <a:bodyPr wrap="square" anchor="t" lIns="0" rIns="0" tIns="0" bIns="0">
+          <a:bodyPr wrap="square" lIns="0" tIns="0" rIns="0" bIns="0" anchor="t">
             <a:spAutoFit/>
           </a:bodyPr>
           <a:lstStyle/>
           <a:p>
             <a:pPr algn="r"/>
-            <a:r>
-              <a:rPr sz="1100" b="0" i="0">
-                <a:solidFill>
-                  <a:srgbClr val="7A7A7A"/>
-                </a:solidFill>
-                <a:latin typeface="Roboto"/>
-              </a:rPr>
-              <a:t/>
-            </a:r>
+            <a:endParaRPr/>
           </a:p>
         </p:txBody>
       </p:sp>
@@ -4333,7 +4791,7 @@
 </file>
 
 <file path=ppt/slides/slide12.xml><?xml version="1.0" encoding="utf-8"?>
-<p:sld xmlns:a="http://schemas.openxmlformats.org/drawingml/2006/main" xmlns:p="http://schemas.openxmlformats.org/presentationml/2006/main" xmlns:r="http://schemas.openxmlformats.org/officeDocument/2006/relationships">
+<p:sld xmlns:a="http://schemas.openxmlformats.org/drawingml/2006/main" xmlns:r="http://schemas.openxmlformats.org/officeDocument/2006/relationships" xmlns:p="http://schemas.openxmlformats.org/presentationml/2006/main">
   <p:cSld>
     <p:bg>
       <p:bgPr>
@@ -4349,7 +4807,14 @@
         <p:cNvGrpSpPr/>
         <p:nvPr/>
       </p:nvGrpSpPr>
-      <p:grpSpPr/>
+      <p:grpSpPr>
+        <a:xfrm>
+          <a:off x="0" y="0"/>
+          <a:ext cx="0" cy="0"/>
+          <a:chOff x="0" y="0"/>
+          <a:chExt cx="0" cy="0"/>
+        </a:xfrm>
+      </p:grpSpPr>
       <p:sp>
         <p:nvSpPr>
           <p:cNvPr id="2" name="TextBox 1"/>
@@ -4367,7 +4832,7 @@
           <a:noFill/>
         </p:spPr>
         <p:txBody>
-          <a:bodyPr wrap="square" anchor="t" lIns="0" rIns="0" tIns="0" bIns="0">
+          <a:bodyPr wrap="square" lIns="0" tIns="0" rIns="0" bIns="0" anchor="t">
             <a:spAutoFit/>
           </a:bodyPr>
           <a:lstStyle/>
@@ -4425,6 +4890,7 @@
           <a:lstStyle/>
           <a:p>
             <a:pPr algn="ctr"/>
+            <a:endParaRPr/>
           </a:p>
         </p:txBody>
       </p:sp>
@@ -4445,7 +4911,7 @@
           <a:noFill/>
         </p:spPr>
         <p:txBody>
-          <a:bodyPr wrap="square" anchor="t" lIns="0" rIns="0" tIns="0" bIns="0">
+          <a:bodyPr wrap="square" lIns="0" tIns="0" rIns="0" bIns="0" anchor="t">
             <a:spAutoFit/>
           </a:bodyPr>
           <a:lstStyle/>
@@ -4530,16 +4996,7 @@
                 </a:solidFill>
                 <a:latin typeface="Roboto"/>
               </a:rPr>
-              <a:t>■  </a:t>
-            </a:r>
-            <a:r>
-              <a:rPr sz="1800" b="1" i="0">
-                <a:solidFill>
-                  <a:srgbClr val="27B5CE"/>
-                </a:solidFill>
-                <a:latin typeface="Roboto"/>
-              </a:rPr>
-              <a:t>The board decides on total cost + benefit, not a monthly price.</a:t>
+              <a:t>■  The board decides on total cost + benefit, not a monthly price.</a:t>
             </a:r>
           </a:p>
         </p:txBody>
@@ -4585,6 +5042,7 @@
           <a:lstStyle/>
           <a:p>
             <a:pPr algn="ctr"/>
+            <a:endParaRPr/>
           </a:p>
         </p:txBody>
       </p:sp>
@@ -4605,7 +5063,7 @@
           <a:noFill/>
         </p:spPr>
         <p:txBody>
-          <a:bodyPr wrap="square" anchor="t" lIns="0" rIns="0" tIns="0" bIns="0">
+          <a:bodyPr wrap="square" lIns="0" tIns="0" rIns="0" bIns="0" anchor="t">
             <a:spAutoFit/>
           </a:bodyPr>
           <a:lstStyle/>
@@ -4648,7 +5106,7 @@
           <a:noFill/>
         </p:spPr>
         <p:txBody>
-          <a:bodyPr wrap="square" anchor="t" lIns="0" rIns="0" tIns="0" bIns="0">
+          <a:bodyPr wrap="square" lIns="0" tIns="0" rIns="0" bIns="0" anchor="t">
             <a:spAutoFit/>
           </a:bodyPr>
           <a:lstStyle/>
@@ -4675,7 +5133,7 @@
 </file>
 
 <file path=ppt/slides/slide13.xml><?xml version="1.0" encoding="utf-8"?>
-<p:sld xmlns:a="http://schemas.openxmlformats.org/drawingml/2006/main" xmlns:p="http://schemas.openxmlformats.org/presentationml/2006/main" xmlns:r="http://schemas.openxmlformats.org/officeDocument/2006/relationships">
+<p:sld xmlns:a="http://schemas.openxmlformats.org/drawingml/2006/main" xmlns:r="http://schemas.openxmlformats.org/officeDocument/2006/relationships" xmlns:p="http://schemas.openxmlformats.org/presentationml/2006/main">
   <p:cSld>
     <p:bg>
       <p:bgPr>
@@ -4691,7 +5149,14 @@
         <p:cNvGrpSpPr/>
         <p:nvPr/>
       </p:nvGrpSpPr>
-      <p:grpSpPr/>
+      <p:grpSpPr>
+        <a:xfrm>
+          <a:off x="0" y="0"/>
+          <a:ext cx="0" cy="0"/>
+          <a:chOff x="0" y="0"/>
+          <a:chExt cx="0" cy="0"/>
+        </a:xfrm>
+      </p:grpSpPr>
       <p:sp>
         <p:nvSpPr>
           <p:cNvPr id="2" name="TextBox 1"/>
@@ -4709,7 +5174,7 @@
           <a:noFill/>
         </p:spPr>
         <p:txBody>
-          <a:bodyPr wrap="square" anchor="t" lIns="0" rIns="0" tIns="0" bIns="0">
+          <a:bodyPr wrap="square" lIns="0" tIns="0" rIns="0" bIns="0" anchor="t">
             <a:spAutoFit/>
           </a:bodyPr>
           <a:lstStyle/>
@@ -4783,6 +5248,7 @@
           <a:lstStyle/>
           <a:p>
             <a:pPr algn="ctr"/>
+            <a:endParaRPr/>
           </a:p>
         </p:txBody>
       </p:sp>
@@ -4803,7 +5269,7 @@
           <a:noFill/>
         </p:spPr>
         <p:txBody>
-          <a:bodyPr wrap="square" anchor="t" lIns="0" rIns="0" tIns="0" bIns="0">
+          <a:bodyPr wrap="square" lIns="0" tIns="0" rIns="0" bIns="0" anchor="t">
             <a:spAutoFit/>
           </a:bodyPr>
           <a:lstStyle/>
@@ -4888,16 +5354,7 @@
                 </a:solidFill>
                 <a:latin typeface="Roboto"/>
               </a:rPr>
-              <a:t>■  </a:t>
-            </a:r>
-            <a:r>
-              <a:rPr sz="1800" b="1" i="0">
-                <a:solidFill>
-                  <a:srgbClr val="27B5CE"/>
-                </a:solidFill>
-                <a:latin typeface="Roboto"/>
-              </a:rPr>
-              <a:t>State every assumption — an unstated assumption is a hole in the case.</a:t>
+              <a:t>■  State every assumption — an unstated assumption is a hole in the case.</a:t>
             </a:r>
           </a:p>
           <a:p>
@@ -4974,6 +5431,7 @@
           <a:lstStyle/>
           <a:p>
             <a:pPr algn="ctr"/>
+            <a:endParaRPr/>
           </a:p>
         </p:txBody>
       </p:sp>
@@ -4994,7 +5452,7 @@
           <a:noFill/>
         </p:spPr>
         <p:txBody>
-          <a:bodyPr wrap="square" anchor="t" lIns="0" rIns="0" tIns="0" bIns="0">
+          <a:bodyPr wrap="square" lIns="0" tIns="0" rIns="0" bIns="0" anchor="t">
             <a:spAutoFit/>
           </a:bodyPr>
           <a:lstStyle/>
@@ -5037,7 +5495,7 @@
           <a:noFill/>
         </p:spPr>
         <p:txBody>
-          <a:bodyPr wrap="square" anchor="t" lIns="0" rIns="0" tIns="0" bIns="0">
+          <a:bodyPr wrap="square" lIns="0" tIns="0" rIns="0" bIns="0" anchor="t">
             <a:spAutoFit/>
           </a:bodyPr>
           <a:lstStyle/>
@@ -5064,7 +5522,7 @@
 </file>
 
 <file path=ppt/slides/slide14.xml><?xml version="1.0" encoding="utf-8"?>
-<p:sld xmlns:a="http://schemas.openxmlformats.org/drawingml/2006/main" xmlns:p="http://schemas.openxmlformats.org/presentationml/2006/main" xmlns:r="http://schemas.openxmlformats.org/officeDocument/2006/relationships">
+<p:sld xmlns:a="http://schemas.openxmlformats.org/drawingml/2006/main" xmlns:r="http://schemas.openxmlformats.org/officeDocument/2006/relationships" xmlns:p="http://schemas.openxmlformats.org/presentationml/2006/main">
   <p:cSld>
     <p:bg>
       <p:bgPr>
@@ -5080,7 +5538,14 @@
         <p:cNvGrpSpPr/>
         <p:nvPr/>
       </p:nvGrpSpPr>
-      <p:grpSpPr/>
+      <p:grpSpPr>
+        <a:xfrm>
+          <a:off x="0" y="0"/>
+          <a:ext cx="0" cy="0"/>
+          <a:chOff x="0" y="0"/>
+          <a:chExt cx="0" cy="0"/>
+        </a:xfrm>
+      </p:grpSpPr>
       <p:sp>
         <p:nvSpPr>
           <p:cNvPr id="2" name="TextBox 1"/>
@@ -5098,7 +5563,7 @@
           <a:noFill/>
         </p:spPr>
         <p:txBody>
-          <a:bodyPr wrap="square" anchor="t" lIns="0" rIns="0" tIns="0" bIns="0">
+          <a:bodyPr wrap="square" lIns="0" tIns="0" rIns="0" bIns="0" anchor="t">
             <a:spAutoFit/>
           </a:bodyPr>
           <a:lstStyle/>
@@ -5156,6 +5621,7 @@
           <a:lstStyle/>
           <a:p>
             <a:pPr algn="ctr"/>
+            <a:endParaRPr/>
           </a:p>
         </p:txBody>
       </p:sp>
@@ -5176,7 +5642,7 @@
           <a:noFill/>
         </p:spPr>
         <p:txBody>
-          <a:bodyPr wrap="square" anchor="t" lIns="0" rIns="0" tIns="0" bIns="0">
+          <a:bodyPr wrap="square" lIns="0" tIns="0" rIns="0" bIns="0" anchor="t">
             <a:spAutoFit/>
           </a:bodyPr>
           <a:lstStyle/>
@@ -5261,16 +5727,7 @@
                 </a:solidFill>
                 <a:latin typeface="Roboto"/>
               </a:rPr>
-              <a:t>■  </a:t>
-            </a:r>
-            <a:r>
-              <a:rPr sz="1800" b="1" i="0">
-                <a:solidFill>
-                  <a:srgbClr val="27B5CE"/>
-                </a:solidFill>
-                <a:latin typeface="Roboto"/>
-              </a:rPr>
-              <a:t>Watch software licensing (Windows / SQL Server) — it rides on BOTH options; don't drop it.</a:t>
+              <a:t>■  Watch software licensing (Windows / SQL Server) — it rides on BOTH options; don't drop it.</a:t>
             </a:r>
           </a:p>
         </p:txBody>
@@ -5316,6 +5773,7 @@
           <a:lstStyle/>
           <a:p>
             <a:pPr algn="ctr"/>
+            <a:endParaRPr/>
           </a:p>
         </p:txBody>
       </p:sp>
@@ -5336,7 +5794,7 @@
           <a:noFill/>
         </p:spPr>
         <p:txBody>
-          <a:bodyPr wrap="square" anchor="t" lIns="0" rIns="0" tIns="0" bIns="0">
+          <a:bodyPr wrap="square" lIns="0" tIns="0" rIns="0" bIns="0" anchor="t">
             <a:spAutoFit/>
           </a:bodyPr>
           <a:lstStyle/>
@@ -5379,7 +5837,7 @@
           <a:noFill/>
         </p:spPr>
         <p:txBody>
-          <a:bodyPr wrap="square" anchor="t" lIns="0" rIns="0" tIns="0" bIns="0">
+          <a:bodyPr wrap="square" lIns="0" tIns="0" rIns="0" bIns="0" anchor="t">
             <a:spAutoFit/>
           </a:bodyPr>
           <a:lstStyle/>
@@ -5406,7 +5864,7 @@
 </file>
 
 <file path=ppt/slides/slide15.xml><?xml version="1.0" encoding="utf-8"?>
-<p:sld xmlns:a="http://schemas.openxmlformats.org/drawingml/2006/main" xmlns:p="http://schemas.openxmlformats.org/presentationml/2006/main" xmlns:r="http://schemas.openxmlformats.org/officeDocument/2006/relationships">
+<p:sld xmlns:a="http://schemas.openxmlformats.org/drawingml/2006/main" xmlns:r="http://schemas.openxmlformats.org/officeDocument/2006/relationships" xmlns:p="http://schemas.openxmlformats.org/presentationml/2006/main">
   <p:cSld>
     <p:bg>
       <p:bgPr>
@@ -5422,7 +5880,14 @@
         <p:cNvGrpSpPr/>
         <p:nvPr/>
       </p:nvGrpSpPr>
-      <p:grpSpPr/>
+      <p:grpSpPr>
+        <a:xfrm>
+          <a:off x="0" y="0"/>
+          <a:ext cx="0" cy="0"/>
+          <a:chOff x="0" y="0"/>
+          <a:chExt cx="0" cy="0"/>
+        </a:xfrm>
+      </p:grpSpPr>
       <p:sp>
         <p:nvSpPr>
           <p:cNvPr id="2" name="TextBox 1"/>
@@ -5440,7 +5905,7 @@
           <a:noFill/>
         </p:spPr>
         <p:txBody>
-          <a:bodyPr wrap="square" anchor="t" lIns="0" rIns="0" tIns="0" bIns="0">
+          <a:bodyPr wrap="square" lIns="0" tIns="0" rIns="0" bIns="0" anchor="t">
             <a:spAutoFit/>
           </a:bodyPr>
           <a:lstStyle/>
@@ -5514,6 +5979,7 @@
           <a:lstStyle/>
           <a:p>
             <a:pPr algn="ctr"/>
+            <a:endParaRPr/>
           </a:p>
         </p:txBody>
       </p:sp>
@@ -5534,7 +6000,7 @@
           <a:noFill/>
         </p:spPr>
         <p:txBody>
-          <a:bodyPr wrap="square" anchor="t" lIns="0" rIns="0" tIns="0" bIns="0">
+          <a:bodyPr wrap="square" lIns="0" tIns="0" rIns="0" bIns="0" anchor="t">
             <a:spAutoFit/>
           </a:bodyPr>
           <a:lstStyle/>
@@ -5697,120 +6163,6 @@
       </p:sp>
       <p:sp>
         <p:nvSpPr>
-          <p:cNvPr id="5" name="Rounded Rectangle 4"/>
-          <p:cNvSpPr/>
-          <p:nvPr/>
-        </p:nvSpPr>
-        <p:spPr>
-          <a:xfrm>
-            <a:off x="6400800" y="1783080"/>
-            <a:ext cx="5120640" cy="4023360"/>
-          </a:xfrm>
-          <a:prstGeom prst="roundRect">
-            <a:avLst/>
-          </a:prstGeom>
-          <a:solidFill>
-            <a:srgbClr val="FBF6E6"/>
-          </a:solidFill>
-          <a:ln w="12700">
-            <a:solidFill>
-              <a:srgbClr val="27B5CE"/>
-            </a:solidFill>
-            <a:prstDash val="dash"/>
-          </a:ln>
-          <a:effectLst/>
-        </p:spPr>
-        <p:style>
-          <a:lnRef idx="1">
-            <a:schemeClr val="accent1"/>
-          </a:lnRef>
-          <a:fillRef idx="3">
-            <a:schemeClr val="accent1"/>
-          </a:fillRef>
-          <a:effectRef idx="2">
-            <a:schemeClr val="accent1"/>
-          </a:effectRef>
-          <a:fontRef idx="minor">
-            <a:schemeClr val="lt1"/>
-          </a:fontRef>
-        </p:style>
-        <p:txBody>
-          <a:bodyPr rtlCol="0" anchor="ctr"/>
-          <a:lstStyle/>
-          <a:p>
-            <a:pPr algn="ctr"/>
-          </a:p>
-        </p:txBody>
-      </p:sp>
-      <p:sp>
-        <p:nvSpPr>
-          <p:cNvPr id="6" name="TextBox 5"/>
-          <p:cNvSpPr txBox="1"/>
-          <p:nvPr/>
-        </p:nvSpPr>
-        <p:spPr>
-          <a:xfrm>
-            <a:off x="6400800" y="1783080"/>
-            <a:ext cx="5120640" cy="4023360"/>
-          </a:xfrm>
-          <a:prstGeom prst="rect">
-            <a:avLst/>
-          </a:prstGeom>
-          <a:noFill/>
-        </p:spPr>
-        <p:txBody>
-          <a:bodyPr wrap="square" anchor="ctr" lIns="0" rIns="0" tIns="0" bIns="0">
-            <a:spAutoFit/>
-          </a:bodyPr>
-          <a:lstStyle/>
-          <a:p>
-            <a:pPr algn="ctr"/>
-            <a:r>
-              <a:rPr sz="3000" b="0" i="0">
-                <a:solidFill>
-                  <a:srgbClr val="27B5CE"/>
-                </a:solidFill>
-                <a:latin typeface="Roboto"/>
-              </a:rPr>
-              <a:t>🖼</a:t>
-            </a:r>
-          </a:p>
-          <a:p>
-            <a:pPr algn="ctr">
-              <a:spcBef>
-                <a:spcPts val="400"/>
-              </a:spcBef>
-            </a:pPr>
-            <a:r>
-              <a:rPr sz="1200" b="1" i="0">
-                <a:solidFill>
-                  <a:srgbClr val="27B5CE"/>
-                </a:solidFill>
-                <a:latin typeface="Roboto"/>
-              </a:rPr>
-              <a:t>IMAGE</a:t>
-            </a:r>
-          </a:p>
-          <a:p>
-            <a:pPr algn="ctr">
-              <a:spcBef>
-                <a:spcPts val="200"/>
-              </a:spcBef>
-            </a:pPr>
-            <a:r>
-              <a:rPr sz="1200" b="0" i="1">
-                <a:solidFill>
-                  <a:srgbClr val="484848"/>
-                </a:solidFill>
-                <a:latin typeface="Roboto Light"/>
-              </a:rPr>
-              <a:t>AWS Pricing Calculator — screenshot</a:t>
-            </a:r>
-          </a:p>
-        </p:txBody>
-      </p:sp>
-      <p:sp>
-        <p:nvSpPr>
           <p:cNvPr id="7" name="Rectangle 6"/>
           <p:cNvSpPr/>
           <p:nvPr/>
@@ -5850,6 +6202,7 @@
           <a:lstStyle/>
           <a:p>
             <a:pPr algn="ctr"/>
+            <a:endParaRPr/>
           </a:p>
         </p:txBody>
       </p:sp>
@@ -5870,7 +6223,7 @@
           <a:noFill/>
         </p:spPr>
         <p:txBody>
-          <a:bodyPr wrap="square" anchor="t" lIns="0" rIns="0" tIns="0" bIns="0">
+          <a:bodyPr wrap="square" lIns="0" tIns="0" rIns="0" bIns="0" anchor="t">
             <a:spAutoFit/>
           </a:bodyPr>
           <a:lstStyle/>
@@ -5913,7 +6266,7 @@
           <a:noFill/>
         </p:spPr>
         <p:txBody>
-          <a:bodyPr wrap="square" anchor="t" lIns="0" rIns="0" tIns="0" bIns="0">
+          <a:bodyPr wrap="square" lIns="0" tIns="0" rIns="0" bIns="0" anchor="t">
             <a:spAutoFit/>
           </a:bodyPr>
           <a:lstStyle/>
@@ -5928,6 +6281,89 @@
               </a:rPr>
               <a:t>12</a:t>
             </a:r>
+          </a:p>
+        </p:txBody>
+      </p:sp>
+      <p:pic>
+        <p:nvPicPr>
+          <p:cNvPr id="10" name="Picture 9" descr="AWS Pricing Calculator website.">
+            <a:extLst>
+              <a:ext uri="{FF2B5EF4-FFF2-40B4-BE49-F238E27FC236}">
+                <a16:creationId xmlns:a16="http://schemas.microsoft.com/office/drawing/2014/main" id="{95B9C72A-111D-DAD9-C6A0-94B048AB7340}"/>
+              </a:ext>
+            </a:extLst>
+          </p:cNvPr>
+          <p:cNvPicPr>
+            <a:picLocks noChangeAspect="1"/>
+          </p:cNvPicPr>
+          <p:nvPr/>
+        </p:nvPicPr>
+        <p:blipFill>
+          <a:blip r:embed="rId3"/>
+          <a:stretch>
+            <a:fillRect/>
+          </a:stretch>
+        </p:blipFill>
+        <p:spPr>
+          <a:xfrm>
+            <a:off x="6334530" y="1554511"/>
+            <a:ext cx="5575239" cy="3259912"/>
+          </a:xfrm>
+          <a:prstGeom prst="rect">
+            <a:avLst/>
+          </a:prstGeom>
+        </p:spPr>
+      </p:pic>
+      <p:sp>
+        <p:nvSpPr>
+          <p:cNvPr id="11" name="TextBox 10">
+            <a:extLst>
+              <a:ext uri="{FF2B5EF4-FFF2-40B4-BE49-F238E27FC236}">
+                <a16:creationId xmlns:a16="http://schemas.microsoft.com/office/drawing/2014/main" id="{3F5B2059-4D5B-5F24-D2BC-166916F6BCCF}"/>
+              </a:ext>
+            </a:extLst>
+          </p:cNvPr>
+          <p:cNvSpPr txBox="1"/>
+          <p:nvPr/>
+        </p:nvSpPr>
+        <p:spPr>
+          <a:xfrm>
+            <a:off x="6748744" y="4841824"/>
+            <a:ext cx="4746812" cy="461665"/>
+          </a:xfrm>
+          <a:prstGeom prst="rect">
+            <a:avLst/>
+          </a:prstGeom>
+          <a:noFill/>
+        </p:spPr>
+        <p:txBody>
+          <a:bodyPr wrap="none" rtlCol="0">
+            <a:spAutoFit/>
+          </a:bodyPr>
+          <a:lstStyle/>
+          <a:p>
+            <a:r>
+              <a:rPr lang="en-US" sz="2400" dirty="0">
+                <a:latin typeface="Amazon Ember Light" panose="020B0403020204020204" pitchFamily="34" charset="0"/>
+                <a:ea typeface="Amazon Ember Light" panose="020B0403020204020204" pitchFamily="34" charset="0"/>
+                <a:cs typeface="Amazon Ember Light" panose="020B0403020204020204" pitchFamily="34" charset="0"/>
+              </a:rPr>
+              <a:t>Access the </a:t>
+            </a:r>
+            <a:r>
+              <a:rPr lang="en-US" sz="2400" dirty="0">
+                <a:latin typeface="Amazon Ember Light" panose="020B0403020204020204" pitchFamily="34" charset="0"/>
+                <a:ea typeface="Amazon Ember Light" panose="020B0403020204020204" pitchFamily="34" charset="0"/>
+                <a:cs typeface="Amazon Ember Light" panose="020B0403020204020204" pitchFamily="34" charset="0"/>
+                <a:hlinkClick r:id="rId4"/>
+              </a:rPr>
+              <a:t>AWS Pricing Calculator</a:t>
+            </a:r>
+            <a:endParaRPr lang="en-US" sz="2400" dirty="0">
+              <a:latin typeface="Amazon Ember Light" panose="020B0403020204020204" pitchFamily="34" charset="0"/>
+              <a:ea typeface="Amazon Ember Light" panose="020B0403020204020204" pitchFamily="34" charset="0"/>
+              <a:cs typeface="Amazon Ember Light" panose="020B0403020204020204" pitchFamily="34" charset="0"/>
+            </a:endParaRPr>
           </a:p>
         </p:txBody>
       </p:sp>
@@ -5940,7 +6376,7 @@
 </file>
 
 <file path=ppt/slides/slide16.xml><?xml version="1.0" encoding="utf-8"?>
-<p:sld xmlns:a="http://schemas.openxmlformats.org/drawingml/2006/main" xmlns:p="http://schemas.openxmlformats.org/presentationml/2006/main" xmlns:r="http://schemas.openxmlformats.org/officeDocument/2006/relationships">
+<p:sld xmlns:a="http://schemas.openxmlformats.org/drawingml/2006/main" xmlns:r="http://schemas.openxmlformats.org/officeDocument/2006/relationships" xmlns:p="http://schemas.openxmlformats.org/presentationml/2006/main">
   <p:cSld>
     <p:bg>
       <p:bgPr>
@@ -5956,7 +6392,14 @@
         <p:cNvGrpSpPr/>
         <p:nvPr/>
       </p:nvGrpSpPr>
-      <p:grpSpPr/>
+      <p:grpSpPr>
+        <a:xfrm>
+          <a:off x="0" y="0"/>
+          <a:ext cx="0" cy="0"/>
+          <a:chOff x="0" y="0"/>
+          <a:chExt cx="0" cy="0"/>
+        </a:xfrm>
+      </p:grpSpPr>
       <p:sp>
         <p:nvSpPr>
           <p:cNvPr id="2" name="Rectangle 1"/>
@@ -5998,6 +6441,7 @@
           <a:lstStyle/>
           <a:p>
             <a:pPr algn="ctr"/>
+            <a:endParaRPr/>
           </a:p>
         </p:txBody>
       </p:sp>
@@ -6038,7 +6482,7 @@
           </a:fontRef>
         </p:style>
         <p:txBody>
-          <a:bodyPr rtlCol="0" anchor="ctr" wrap="none"/>
+          <a:bodyPr wrap="none" rtlCol="0" anchor="ctr"/>
           <a:lstStyle/>
           <a:p>
             <a:pPr algn="ctr"/>
@@ -6071,7 +6515,7 @@
           <a:noFill/>
         </p:spPr>
         <p:txBody>
-          <a:bodyPr wrap="square" anchor="ctr" lIns="0" rIns="0" tIns="0" bIns="0">
+          <a:bodyPr wrap="square" lIns="0" tIns="0" rIns="0" bIns="0" anchor="ctr">
             <a:spAutoFit/>
           </a:bodyPr>
           <a:lstStyle/>
@@ -6105,7 +6549,7 @@
           <a:noFill/>
         </p:spPr>
         <p:txBody>
-          <a:bodyPr wrap="square" anchor="t" lIns="0" rIns="0" tIns="0" bIns="0">
+          <a:bodyPr wrap="square" lIns="0" tIns="0" rIns="0" bIns="0" anchor="t">
             <a:spAutoFit/>
           </a:bodyPr>
           <a:lstStyle/>
@@ -6122,7 +6566,7 @@
               </a:spcAft>
             </a:pPr>
             <a:r>
-              <a:rPr sz="1700" b="1" i="0">
+              <a:rPr sz="1700" b="1" i="0" dirty="0">
                 <a:solidFill>
                   <a:srgbClr val="EDAB0C"/>
                 </a:solidFill>
@@ -6131,7 +6575,7 @@
               <a:t>■  </a:t>
             </a:r>
             <a:r>
-              <a:rPr sz="1700" b="1" i="0">
+              <a:rPr sz="1700" b="1" i="0" dirty="0">
                 <a:solidFill>
                   <a:srgbClr val="2A2929"/>
                 </a:solidFill>
@@ -6153,7 +6597,7 @@
               </a:spcAft>
             </a:pPr>
             <a:r>
-              <a:rPr sz="1700" b="1" i="0">
+              <a:rPr sz="1700" b="1" i="0" dirty="0">
                 <a:solidFill>
                   <a:srgbClr val="EDAB0C"/>
                 </a:solidFill>
@@ -6162,7 +6606,7 @@
               <a:t>■  </a:t>
             </a:r>
             <a:r>
-              <a:rPr sz="1700" b="0" i="0">
+              <a:rPr sz="1700" b="0" i="0" dirty="0">
                 <a:solidFill>
                   <a:srgbClr val="2A2929"/>
                 </a:solidFill>
@@ -6184,7 +6628,7 @@
               </a:spcAft>
             </a:pPr>
             <a:r>
-              <a:rPr sz="1400" b="0" i="0">
+              <a:rPr sz="1400" b="0" i="0" dirty="0">
                 <a:solidFill>
                   <a:srgbClr val="7A7A7A"/>
                 </a:solidFill>
@@ -6193,7 +6637,7 @@
               <a:t>–  </a:t>
             </a:r>
             <a:r>
-              <a:rPr sz="1400" b="0" i="0">
+              <a:rPr sz="1400" b="0" i="0" dirty="0">
                 <a:solidFill>
                   <a:srgbClr val="2A2929"/>
                 </a:solidFill>
@@ -6215,7 +6659,7 @@
               </a:spcAft>
             </a:pPr>
             <a:r>
-              <a:rPr sz="1400" b="0" i="0">
+              <a:rPr sz="1400" b="0" i="0" dirty="0">
                 <a:solidFill>
                   <a:srgbClr val="7A7A7A"/>
                 </a:solidFill>
@@ -6224,7 +6668,7 @@
               <a:t>–  </a:t>
             </a:r>
             <a:r>
-              <a:rPr sz="1400" b="0" i="0">
+              <a:rPr sz="1400" b="0" i="0" dirty="0">
                 <a:solidFill>
                   <a:srgbClr val="2A2929"/>
                 </a:solidFill>
@@ -6246,7 +6690,7 @@
               </a:spcAft>
             </a:pPr>
             <a:r>
-              <a:rPr sz="1400" b="0" i="0">
+              <a:rPr sz="1400" b="0" i="0" dirty="0">
                 <a:solidFill>
                   <a:srgbClr val="7A7A7A"/>
                 </a:solidFill>
@@ -6255,7 +6699,7 @@
               <a:t>–  </a:t>
             </a:r>
             <a:r>
-              <a:rPr sz="1400" b="0" i="0">
+              <a:rPr sz="1400" b="0" i="0" dirty="0">
                 <a:solidFill>
                   <a:srgbClr val="2A2929"/>
                 </a:solidFill>
@@ -6277,7 +6721,7 @@
               </a:spcAft>
             </a:pPr>
             <a:r>
-              <a:rPr sz="1700" b="1" i="0">
+              <a:rPr sz="1700" b="1" i="0" dirty="0">
                 <a:solidFill>
                   <a:srgbClr val="27B5CE"/>
                 </a:solidFill>
@@ -6286,7 +6730,7 @@
               <a:t>■  </a:t>
             </a:r>
             <a:r>
-              <a:rPr sz="1700" b="0" i="0">
+              <a:rPr sz="1700" b="0" i="0" dirty="0">
                 <a:solidFill>
                   <a:srgbClr val="27B5CE"/>
                 </a:solidFill>
@@ -6308,7 +6752,7 @@
               </a:spcAft>
             </a:pPr>
             <a:r>
-              <a:rPr sz="1700" b="1" i="0">
+              <a:rPr sz="1700" b="1" i="0" dirty="0">
                 <a:solidFill>
                   <a:srgbClr val="EDAB0C"/>
                 </a:solidFill>
@@ -6317,14 +6761,29 @@
               <a:t>■  </a:t>
             </a:r>
             <a:r>
-              <a:rPr sz="1700" b="0" i="0">
+              <a:rPr sz="1700" b="0" i="0" dirty="0">
                 <a:solidFill>
                   <a:srgbClr val="484848"/>
                 </a:solidFill>
                 <a:latin typeface="Roboto"/>
               </a:rPr>
-              <a:t>🔗  calculator.aws</a:t>
-            </a:r>
+              <a:t>🔗  </a:t>
+            </a:r>
+            <a:r>
+              <a:rPr sz="1700" b="0" i="0" dirty="0" err="1">
+                <a:solidFill>
+                  <a:srgbClr val="484848"/>
+                </a:solidFill>
+                <a:latin typeface="Roboto"/>
+              </a:rPr>
+              <a:t>calculator.aws</a:t>
+            </a:r>
+            <a:endParaRPr sz="1700" b="0" i="0" dirty="0">
+              <a:solidFill>
+                <a:srgbClr val="484848"/>
+              </a:solidFill>
+              <a:latin typeface="Roboto"/>
+            </a:endParaRPr>
           </a:p>
         </p:txBody>
       </p:sp>
@@ -6371,6 +6830,7 @@
           <a:lstStyle/>
           <a:p>
             <a:pPr algn="ctr"/>
+            <a:endParaRPr/>
           </a:p>
         </p:txBody>
       </p:sp>
@@ -6391,7 +6851,7 @@
           <a:noFill/>
         </p:spPr>
         <p:txBody>
-          <a:bodyPr wrap="square" anchor="ctr" lIns="0" rIns="0" tIns="0" bIns="0">
+          <a:bodyPr wrap="square" lIns="0" tIns="0" rIns="0" bIns="0" anchor="ctr">
             <a:spAutoFit/>
           </a:bodyPr>
           <a:lstStyle/>
@@ -6449,6 +6909,7 @@
           <a:lstStyle/>
           <a:p>
             <a:pPr algn="ctr"/>
+            <a:endParaRPr/>
           </a:p>
         </p:txBody>
       </p:sp>
@@ -6469,7 +6930,7 @@
           <a:noFill/>
         </p:spPr>
         <p:txBody>
-          <a:bodyPr wrap="square" anchor="t" lIns="0" rIns="0" tIns="0" bIns="0">
+          <a:bodyPr wrap="square" lIns="0" tIns="0" rIns="0" bIns="0" anchor="t">
             <a:spAutoFit/>
           </a:bodyPr>
           <a:lstStyle/>
@@ -6512,7 +6973,7 @@
           <a:noFill/>
         </p:spPr>
         <p:txBody>
-          <a:bodyPr wrap="square" anchor="t" lIns="0" rIns="0" tIns="0" bIns="0">
+          <a:bodyPr wrap="square" lIns="0" tIns="0" rIns="0" bIns="0" anchor="t">
             <a:spAutoFit/>
           </a:bodyPr>
           <a:lstStyle/>
@@ -6530,6 +6991,204 @@
           </a:p>
         </p:txBody>
       </p:sp>
+      <p:grpSp>
+        <p:nvGrpSpPr>
+          <p:cNvPr id="11" name="Group 10" descr="Choosing the create estimate button to open the Pricing Calculator tool.">
+            <a:extLst>
+              <a:ext uri="{FF2B5EF4-FFF2-40B4-BE49-F238E27FC236}">
+                <a16:creationId xmlns:a16="http://schemas.microsoft.com/office/drawing/2014/main" id="{0DBFEC46-9CEB-D6AE-68EA-944EEE082022}"/>
+              </a:ext>
+            </a:extLst>
+          </p:cNvPr>
+          <p:cNvGrpSpPr/>
+          <p:nvPr/>
+        </p:nvGrpSpPr>
+        <p:grpSpPr>
+          <a:xfrm>
+            <a:off x="2990712" y="3806388"/>
+            <a:ext cx="8100335" cy="2365812"/>
+            <a:chOff x="337813" y="2816435"/>
+            <a:chExt cx="11516375" cy="3405498"/>
+          </a:xfrm>
+        </p:grpSpPr>
+        <p:grpSp>
+          <p:nvGrpSpPr>
+            <p:cNvPr id="12" name="Group 11" descr="Screenshot of AWS Pricing Calculator website and tool.">
+              <a:extLst>
+                <a:ext uri="{FF2B5EF4-FFF2-40B4-BE49-F238E27FC236}">
+                  <a16:creationId xmlns:a16="http://schemas.microsoft.com/office/drawing/2014/main" id="{8E3B2791-A466-9375-2B42-E979E2FFD0D4}"/>
+                </a:ext>
+              </a:extLst>
+            </p:cNvPr>
+            <p:cNvGrpSpPr/>
+            <p:nvPr/>
+          </p:nvGrpSpPr>
+          <p:grpSpPr>
+            <a:xfrm>
+              <a:off x="337813" y="2816435"/>
+              <a:ext cx="11516375" cy="3405498"/>
+              <a:chOff x="449698" y="2576595"/>
+              <a:chExt cx="11516375" cy="3405498"/>
+            </a:xfrm>
+          </p:grpSpPr>
+          <p:pic>
+            <p:nvPicPr>
+              <p:cNvPr id="14" name="Picture 13" descr="screenshot of create estimate button on AWS Pricing Calculator website.">
+                <a:extLst>
+                  <a:ext uri="{FF2B5EF4-FFF2-40B4-BE49-F238E27FC236}">
+                    <a16:creationId xmlns:a16="http://schemas.microsoft.com/office/drawing/2014/main" id="{767AA6D4-5392-3B1C-42DD-977ECA5CAE61}"/>
+                  </a:ext>
+                </a:extLst>
+              </p:cNvPr>
+              <p:cNvPicPr>
+                <a:picLocks noChangeAspect="1"/>
+              </p:cNvPicPr>
+              <p:nvPr/>
+            </p:nvPicPr>
+            <p:blipFill>
+              <a:blip r:embed="rId2"/>
+              <a:stretch>
+                <a:fillRect/>
+              </a:stretch>
+            </p:blipFill>
+            <p:spPr>
+              <a:xfrm>
+                <a:off x="449698" y="2782726"/>
+                <a:ext cx="4881805" cy="2139685"/>
+              </a:xfrm>
+              <a:prstGeom prst="rect">
+                <a:avLst/>
+              </a:prstGeom>
+            </p:spPr>
+          </p:pic>
+          <p:pic>
+            <p:nvPicPr>
+              <p:cNvPr id="15" name="Picture 14" descr="Screenshot of AWS Pricing Calculator tool.">
+                <a:extLst>
+                  <a:ext uri="{FF2B5EF4-FFF2-40B4-BE49-F238E27FC236}">
+                    <a16:creationId xmlns:a16="http://schemas.microsoft.com/office/drawing/2014/main" id="{8959ABA3-FEBF-6A9F-AFD7-D634B5C569DF}"/>
+                  </a:ext>
+                </a:extLst>
+              </p:cNvPr>
+              <p:cNvPicPr>
+                <a:picLocks noChangeAspect="1"/>
+              </p:cNvPicPr>
+              <p:nvPr/>
+            </p:nvPicPr>
+            <p:blipFill>
+              <a:blip r:embed="rId3"/>
+              <a:stretch>
+                <a:fillRect/>
+              </a:stretch>
+            </p:blipFill>
+            <p:spPr>
+              <a:xfrm>
+                <a:off x="6420742" y="2576595"/>
+                <a:ext cx="5545331" cy="3405498"/>
+              </a:xfrm>
+              <a:prstGeom prst="rect">
+                <a:avLst/>
+              </a:prstGeom>
+            </p:spPr>
+          </p:pic>
+          <p:sp>
+            <p:nvSpPr>
+              <p:cNvPr id="16" name="Oval 15">
+                <a:extLst>
+                  <a:ext uri="{FF2B5EF4-FFF2-40B4-BE49-F238E27FC236}">
+                    <a16:creationId xmlns:a16="http://schemas.microsoft.com/office/drawing/2014/main" id="{D1585B64-B92B-38B5-2E1F-984C1CBF7405}"/>
+                  </a:ext>
+                </a:extLst>
+              </p:cNvPr>
+              <p:cNvSpPr/>
+              <p:nvPr/>
+            </p:nvSpPr>
+            <p:spPr>
+              <a:xfrm>
+                <a:off x="496136" y="4092477"/>
+                <a:ext cx="1947263" cy="754984"/>
+              </a:xfrm>
+              <a:prstGeom prst="ellipse">
+                <a:avLst/>
+              </a:prstGeom>
+              <a:noFill/>
+              <a:ln w="38100">
+                <a:solidFill>
+                  <a:schemeClr val="tx2"/>
+                </a:solidFill>
+              </a:ln>
+            </p:spPr>
+            <p:style>
+              <a:lnRef idx="2">
+                <a:schemeClr val="accent1">
+                  <a:shade val="50000"/>
+                </a:schemeClr>
+              </a:lnRef>
+              <a:fillRef idx="1">
+                <a:schemeClr val="accent1"/>
+              </a:fillRef>
+              <a:effectRef idx="0">
+                <a:schemeClr val="accent1"/>
+              </a:effectRef>
+              <a:fontRef idx="minor">
+                <a:schemeClr val="lt1"/>
+              </a:fontRef>
+            </p:style>
+            <p:txBody>
+              <a:bodyPr rtlCol="0" anchor="ctr"/>
+              <a:lstStyle/>
+              <a:p>
+                <a:pPr algn="ctr"/>
+                <a:endParaRPr lang="en-US"/>
+              </a:p>
+            </p:txBody>
+          </p:sp>
+        </p:grpSp>
+        <p:cxnSp>
+          <p:nvCxnSpPr>
+            <p:cNvPr id="13" name="Elbow Connector 9">
+              <a:extLst>
+                <a:ext uri="{FF2B5EF4-FFF2-40B4-BE49-F238E27FC236}">
+                  <a16:creationId xmlns:a16="http://schemas.microsoft.com/office/drawing/2014/main" id="{22B2C05C-33CA-4A0B-A12E-0150FF500C37}"/>
+                </a:ext>
+              </a:extLst>
+            </p:cNvPr>
+            <p:cNvCxnSpPr/>
+            <p:nvPr/>
+          </p:nvCxnSpPr>
+          <p:spPr>
+            <a:xfrm flipV="1">
+              <a:off x="2331514" y="3591098"/>
+              <a:ext cx="3977343" cy="1080655"/>
+            </a:xfrm>
+            <a:prstGeom prst="bentConnector3">
+              <a:avLst>
+                <a:gd name="adj1" fmla="val 82604"/>
+              </a:avLst>
+            </a:prstGeom>
+            <a:ln w="38100">
+              <a:solidFill>
+                <a:schemeClr val="tx2"/>
+              </a:solidFill>
+              <a:tailEnd type="triangle"/>
+            </a:ln>
+          </p:spPr>
+          <p:style>
+            <a:lnRef idx="1">
+              <a:schemeClr val="accent1"/>
+            </a:lnRef>
+            <a:fillRef idx="0">
+              <a:schemeClr val="accent1"/>
+            </a:fillRef>
+            <a:effectRef idx="0">
+              <a:schemeClr val="accent1"/>
+            </a:effectRef>
+            <a:fontRef idx="minor">
+              <a:schemeClr val="tx1"/>
+            </a:fontRef>
+          </p:style>
+        </p:cxnSp>
+      </p:grpSp>
     </p:spTree>
   </p:cSld>
   <p:clrMapOvr>
@@ -6539,7 +7198,7 @@
 </file>
 
 <file path=ppt/slides/slide17.xml><?xml version="1.0" encoding="utf-8"?>
-<p:sld xmlns:a="http://schemas.openxmlformats.org/drawingml/2006/main" xmlns:p="http://schemas.openxmlformats.org/presentationml/2006/main" xmlns:r="http://schemas.openxmlformats.org/officeDocument/2006/relationships">
+<p:sld xmlns:a="http://schemas.openxmlformats.org/drawingml/2006/main" xmlns:r="http://schemas.openxmlformats.org/officeDocument/2006/relationships" xmlns:p="http://schemas.openxmlformats.org/presentationml/2006/main">
   <p:cSld>
     <p:bg>
       <p:bgPr>
@@ -6555,7 +7214,14 @@
         <p:cNvGrpSpPr/>
         <p:nvPr/>
       </p:nvGrpSpPr>
-      <p:grpSpPr/>
+      <p:grpSpPr>
+        <a:xfrm>
+          <a:off x="0" y="0"/>
+          <a:ext cx="0" cy="0"/>
+          <a:chOff x="0" y="0"/>
+          <a:chExt cx="0" cy="0"/>
+        </a:xfrm>
+      </p:grpSpPr>
       <p:sp>
         <p:nvSpPr>
           <p:cNvPr id="2" name="TextBox 1"/>
@@ -6573,7 +7239,7 @@
           <a:noFill/>
         </p:spPr>
         <p:txBody>
-          <a:bodyPr wrap="square" anchor="t" lIns="0" rIns="0" tIns="0" bIns="0">
+          <a:bodyPr wrap="square" lIns="0" tIns="0" rIns="0" bIns="0" anchor="t">
             <a:spAutoFit/>
           </a:bodyPr>
           <a:lstStyle/>
@@ -6647,6 +7313,7 @@
           <a:lstStyle/>
           <a:p>
             <a:pPr algn="ctr"/>
+            <a:endParaRPr/>
           </a:p>
         </p:txBody>
       </p:sp>
@@ -6667,7 +7334,7 @@
           <a:noFill/>
         </p:spPr>
         <p:txBody>
-          <a:bodyPr wrap="square" anchor="t" lIns="0" rIns="0" tIns="0" bIns="0">
+          <a:bodyPr wrap="square" lIns="0" tIns="0" rIns="0" bIns="0" anchor="t">
             <a:spAutoFit/>
           </a:bodyPr>
           <a:lstStyle/>
@@ -6783,16 +7450,7 @@
                 </a:solidFill>
                 <a:latin typeface="Roboto"/>
               </a:rPr>
-              <a:t>■  </a:t>
-            </a:r>
-            <a:r>
-              <a:rPr sz="1800" b="1" i="0">
-                <a:solidFill>
-                  <a:srgbClr val="27B5CE"/>
-                </a:solidFill>
-                <a:latin typeface="Roboto"/>
-              </a:rPr>
-              <a:t>A CBA with no sensitivity check reads as overconfident.</a:t>
+              <a:t>■  A CBA with no sensitivity check reads as overconfident.</a:t>
             </a:r>
           </a:p>
         </p:txBody>
@@ -6838,6 +7496,7 @@
           <a:lstStyle/>
           <a:p>
             <a:pPr algn="ctr"/>
+            <a:endParaRPr/>
           </a:p>
         </p:txBody>
       </p:sp>
@@ -6858,7 +7517,7 @@
           <a:noFill/>
         </p:spPr>
         <p:txBody>
-          <a:bodyPr wrap="square" anchor="t" lIns="0" rIns="0" tIns="0" bIns="0">
+          <a:bodyPr wrap="square" lIns="0" tIns="0" rIns="0" bIns="0" anchor="t">
             <a:spAutoFit/>
           </a:bodyPr>
           <a:lstStyle/>
@@ -6901,7 +7560,7 @@
           <a:noFill/>
         </p:spPr>
         <p:txBody>
-          <a:bodyPr wrap="square" anchor="t" lIns="0" rIns="0" tIns="0" bIns="0">
+          <a:bodyPr wrap="square" lIns="0" tIns="0" rIns="0" bIns="0" anchor="t">
             <a:spAutoFit/>
           </a:bodyPr>
           <a:lstStyle/>
@@ -6928,7 +7587,7 @@
 </file>
 
 <file path=ppt/slides/slide18.xml><?xml version="1.0" encoding="utf-8"?>
-<p:sld xmlns:a="http://schemas.openxmlformats.org/drawingml/2006/main" xmlns:p="http://schemas.openxmlformats.org/presentationml/2006/main" xmlns:r="http://schemas.openxmlformats.org/officeDocument/2006/relationships">
+<p:sld xmlns:a="http://schemas.openxmlformats.org/drawingml/2006/main" xmlns:r="http://schemas.openxmlformats.org/officeDocument/2006/relationships" xmlns:p="http://schemas.openxmlformats.org/presentationml/2006/main">
   <p:cSld>
     <p:bg>
       <p:bgPr>
@@ -6944,7 +7603,14 @@
         <p:cNvGrpSpPr/>
         <p:nvPr/>
       </p:nvGrpSpPr>
-      <p:grpSpPr/>
+      <p:grpSpPr>
+        <a:xfrm>
+          <a:off x="0" y="0"/>
+          <a:ext cx="0" cy="0"/>
+          <a:chOff x="0" y="0"/>
+          <a:chExt cx="0" cy="0"/>
+        </a:xfrm>
+      </p:grpSpPr>
       <p:sp>
         <p:nvSpPr>
           <p:cNvPr id="2" name="Rectangle 1"/>
@@ -6986,6 +7652,7 @@
           <a:lstStyle/>
           <a:p>
             <a:pPr algn="ctr"/>
+            <a:endParaRPr/>
           </a:p>
         </p:txBody>
       </p:sp>
@@ -7026,7 +7693,7 @@
           </a:fontRef>
         </p:style>
         <p:txBody>
-          <a:bodyPr rtlCol="0" anchor="ctr" wrap="none"/>
+          <a:bodyPr wrap="none" rtlCol="0" anchor="ctr"/>
           <a:lstStyle/>
           <a:p>
             <a:pPr algn="ctr"/>
@@ -7059,7 +7726,7 @@
           <a:noFill/>
         </p:spPr>
         <p:txBody>
-          <a:bodyPr wrap="square" anchor="ctr" lIns="0" rIns="0" tIns="0" bIns="0">
+          <a:bodyPr wrap="square" lIns="0" tIns="0" rIns="0" bIns="0" anchor="ctr">
             <a:spAutoFit/>
           </a:bodyPr>
           <a:lstStyle/>
@@ -7093,7 +7760,7 @@
           <a:noFill/>
         </p:spPr>
         <p:txBody>
-          <a:bodyPr wrap="square" anchor="t" lIns="0" rIns="0" tIns="0" bIns="0">
+          <a:bodyPr wrap="square" lIns="0" tIns="0" rIns="0" bIns="0" anchor="t">
             <a:spAutoFit/>
           </a:bodyPr>
           <a:lstStyle/>
@@ -7359,6 +8026,7 @@
           <a:lstStyle/>
           <a:p>
             <a:pPr algn="ctr"/>
+            <a:endParaRPr/>
           </a:p>
         </p:txBody>
       </p:sp>
@@ -7379,7 +8047,7 @@
           <a:noFill/>
         </p:spPr>
         <p:txBody>
-          <a:bodyPr wrap="square" anchor="ctr" lIns="0" rIns="0" tIns="0" bIns="0">
+          <a:bodyPr wrap="square" lIns="0" tIns="0" rIns="0" bIns="0" anchor="ctr">
             <a:spAutoFit/>
           </a:bodyPr>
           <a:lstStyle/>
@@ -7437,6 +8105,7 @@
           <a:lstStyle/>
           <a:p>
             <a:pPr algn="ctr"/>
+            <a:endParaRPr/>
           </a:p>
         </p:txBody>
       </p:sp>
@@ -7457,7 +8126,7 @@
           <a:noFill/>
         </p:spPr>
         <p:txBody>
-          <a:bodyPr wrap="square" anchor="t" lIns="0" rIns="0" tIns="0" bIns="0">
+          <a:bodyPr wrap="square" lIns="0" tIns="0" rIns="0" bIns="0" anchor="t">
             <a:spAutoFit/>
           </a:bodyPr>
           <a:lstStyle/>
@@ -7500,7 +8169,7 @@
           <a:noFill/>
         </p:spPr>
         <p:txBody>
-          <a:bodyPr wrap="square" anchor="t" lIns="0" rIns="0" tIns="0" bIns="0">
+          <a:bodyPr wrap="square" lIns="0" tIns="0" rIns="0" bIns="0" anchor="t">
             <a:spAutoFit/>
           </a:bodyPr>
           <a:lstStyle/>
@@ -7527,7 +8196,7 @@
 </file>
 
 <file path=ppt/slides/slide19.xml><?xml version="1.0" encoding="utf-8"?>
-<p:sld xmlns:a="http://schemas.openxmlformats.org/drawingml/2006/main" xmlns:p="http://schemas.openxmlformats.org/presentationml/2006/main" xmlns:r="http://schemas.openxmlformats.org/officeDocument/2006/relationships">
+<p:sld xmlns:a="http://schemas.openxmlformats.org/drawingml/2006/main" xmlns:r="http://schemas.openxmlformats.org/officeDocument/2006/relationships" xmlns:p="http://schemas.openxmlformats.org/presentationml/2006/main">
   <p:cSld>
     <p:bg>
       <p:bgPr>
@@ -7543,7 +8212,14 @@
         <p:cNvGrpSpPr/>
         <p:nvPr/>
       </p:nvGrpSpPr>
-      <p:grpSpPr/>
+      <p:grpSpPr>
+        <a:xfrm>
+          <a:off x="0" y="0"/>
+          <a:ext cx="0" cy="0"/>
+          <a:chOff x="0" y="0"/>
+          <a:chExt cx="0" cy="0"/>
+        </a:xfrm>
+      </p:grpSpPr>
       <p:sp>
         <p:nvSpPr>
           <p:cNvPr id="2" name="TextBox 1"/>
@@ -7561,7 +8237,7 @@
           <a:noFill/>
         </p:spPr>
         <p:txBody>
-          <a:bodyPr wrap="square" anchor="t" lIns="0" rIns="0" tIns="0" bIns="0">
+          <a:bodyPr wrap="square" lIns="0" tIns="0" rIns="0" bIns="0" anchor="t">
             <a:spAutoFit/>
           </a:bodyPr>
           <a:lstStyle/>
@@ -7635,6 +8311,7 @@
           <a:lstStyle/>
           <a:p>
             <a:pPr algn="ctr"/>
+            <a:endParaRPr/>
           </a:p>
         </p:txBody>
       </p:sp>
@@ -7681,6 +8358,7 @@
           <a:lstStyle/>
           <a:p>
             <a:pPr algn="ctr"/>
+            <a:endParaRPr/>
           </a:p>
         </p:txBody>
       </p:sp>
@@ -7725,6 +8403,7 @@
           <a:lstStyle/>
           <a:p>
             <a:pPr algn="ctr"/>
+            <a:endParaRPr/>
           </a:p>
         </p:txBody>
       </p:sp>
@@ -7745,7 +8424,7 @@
           <a:noFill/>
         </p:spPr>
         <p:txBody>
-          <a:bodyPr wrap="square" anchor="ctr" lIns="0" rIns="0" tIns="0" bIns="0">
+          <a:bodyPr wrap="square" lIns="0" tIns="0" rIns="0" bIns="0" anchor="ctr">
             <a:spAutoFit/>
           </a:bodyPr>
           <a:lstStyle/>
@@ -7810,6 +8489,7 @@
           <a:lstStyle/>
           <a:p>
             <a:pPr algn="ctr"/>
+            <a:endParaRPr/>
           </a:p>
         </p:txBody>
       </p:sp>
@@ -7854,6 +8534,7 @@
           <a:lstStyle/>
           <a:p>
             <a:pPr algn="ctr"/>
+            <a:endParaRPr/>
           </a:p>
         </p:txBody>
       </p:sp>
@@ -7874,7 +8555,7 @@
           <a:noFill/>
         </p:spPr>
         <p:txBody>
-          <a:bodyPr wrap="square" anchor="ctr" lIns="0" rIns="0" tIns="0" bIns="0">
+          <a:bodyPr wrap="square" lIns="0" tIns="0" rIns="0" bIns="0" anchor="ctr">
             <a:spAutoFit/>
           </a:bodyPr>
           <a:lstStyle/>
@@ -7939,6 +8620,7 @@
           <a:lstStyle/>
           <a:p>
             <a:pPr algn="ctr"/>
+            <a:endParaRPr/>
           </a:p>
         </p:txBody>
       </p:sp>
@@ -7983,6 +8665,7 @@
           <a:lstStyle/>
           <a:p>
             <a:pPr algn="ctr"/>
+            <a:endParaRPr/>
           </a:p>
         </p:txBody>
       </p:sp>
@@ -8003,7 +8686,7 @@
           <a:noFill/>
         </p:spPr>
         <p:txBody>
-          <a:bodyPr wrap="square" anchor="ctr" lIns="0" rIns="0" tIns="0" bIns="0">
+          <a:bodyPr wrap="square" lIns="0" tIns="0" rIns="0" bIns="0" anchor="ctr">
             <a:spAutoFit/>
           </a:bodyPr>
           <a:lstStyle/>
@@ -8068,6 +8751,7 @@
           <a:lstStyle/>
           <a:p>
             <a:pPr algn="ctr"/>
+            <a:endParaRPr/>
           </a:p>
         </p:txBody>
       </p:sp>
@@ -8112,6 +8796,7 @@
           <a:lstStyle/>
           <a:p>
             <a:pPr algn="ctr"/>
+            <a:endParaRPr/>
           </a:p>
         </p:txBody>
       </p:sp>
@@ -8132,7 +8817,7 @@
           <a:noFill/>
         </p:spPr>
         <p:txBody>
-          <a:bodyPr wrap="square" anchor="ctr" lIns="0" rIns="0" tIns="0" bIns="0">
+          <a:bodyPr wrap="square" lIns="0" tIns="0" rIns="0" bIns="0" anchor="ctr">
             <a:spAutoFit/>
           </a:bodyPr>
           <a:lstStyle/>
@@ -8195,6 +8880,7 @@
           <a:lstStyle/>
           <a:p>
             <a:pPr algn="ctr"/>
+            <a:endParaRPr/>
           </a:p>
         </p:txBody>
       </p:sp>
@@ -8215,7 +8901,7 @@
           <a:noFill/>
         </p:spPr>
         <p:txBody>
-          <a:bodyPr wrap="square" anchor="t" lIns="0" rIns="0" tIns="0" bIns="0">
+          <a:bodyPr wrap="square" lIns="0" tIns="0" rIns="0" bIns="0" anchor="t">
             <a:spAutoFit/>
           </a:bodyPr>
           <a:lstStyle/>
@@ -8258,7 +8944,7 @@
           <a:noFill/>
         </p:spPr>
         <p:txBody>
-          <a:bodyPr wrap="square" anchor="t" lIns="0" rIns="0" tIns="0" bIns="0">
+          <a:bodyPr wrap="square" lIns="0" tIns="0" rIns="0" bIns="0" anchor="t">
             <a:spAutoFit/>
           </a:bodyPr>
           <a:lstStyle/>
@@ -8285,7 +8971,7 @@
 </file>
 
 <file path=ppt/slides/slide2.xml><?xml version="1.0" encoding="utf-8"?>
-<p:sld xmlns:a="http://schemas.openxmlformats.org/drawingml/2006/main" xmlns:p="http://schemas.openxmlformats.org/presentationml/2006/main" xmlns:r="http://schemas.openxmlformats.org/officeDocument/2006/relationships">
+<p:sld xmlns:a="http://schemas.openxmlformats.org/drawingml/2006/main" xmlns:r="http://schemas.openxmlformats.org/officeDocument/2006/relationships" xmlns:p="http://schemas.openxmlformats.org/presentationml/2006/main">
   <p:cSld>
     <p:bg>
       <p:bgPr>
@@ -8301,7 +8987,14 @@
         <p:cNvGrpSpPr/>
         <p:nvPr/>
       </p:nvGrpSpPr>
-      <p:grpSpPr/>
+      <p:grpSpPr>
+        <a:xfrm>
+          <a:off x="0" y="0"/>
+          <a:ext cx="0" cy="0"/>
+          <a:chOff x="0" y="0"/>
+          <a:chExt cx="0" cy="0"/>
+        </a:xfrm>
+      </p:grpSpPr>
       <p:sp>
         <p:nvSpPr>
           <p:cNvPr id="2" name="TextBox 1"/>
@@ -8319,7 +9012,7 @@
           <a:noFill/>
         </p:spPr>
         <p:txBody>
-          <a:bodyPr wrap="square" anchor="t" lIns="0" rIns="0" tIns="0" bIns="0">
+          <a:bodyPr wrap="square" lIns="0" tIns="0" rIns="0" bIns="0" anchor="t">
             <a:spAutoFit/>
           </a:bodyPr>
           <a:lstStyle/>
@@ -8393,6 +9086,7 @@
           <a:lstStyle/>
           <a:p>
             <a:pPr algn="ctr"/>
+            <a:endParaRPr/>
           </a:p>
         </p:txBody>
       </p:sp>
@@ -8413,7 +9107,7 @@
           <a:noFill/>
         </p:spPr>
         <p:txBody>
-          <a:bodyPr wrap="square" anchor="t" lIns="0" rIns="0" tIns="0" bIns="0">
+          <a:bodyPr wrap="square" lIns="0" tIns="0" rIns="0" bIns="0" anchor="t">
             <a:spAutoFit/>
           </a:bodyPr>
           <a:lstStyle/>
@@ -8467,16 +9161,7 @@
                 </a:solidFill>
                 <a:latin typeface="Roboto"/>
               </a:rPr>
-              <a:t>■  </a:t>
-            </a:r>
-            <a:r>
-              <a:rPr sz="1800" b="1" i="0">
-                <a:solidFill>
-                  <a:srgbClr val="92268F"/>
-                </a:solidFill>
-                <a:latin typeface="Roboto"/>
-              </a:rPr>
-              <a:t>Three moves: lay out the options → cost them over time → weigh the risks.</a:t>
+              <a:t>■  Three moves: lay out the options → cost them over time → weigh the risks.</a:t>
             </a:r>
           </a:p>
           <a:p>
@@ -8584,6 +9269,7 @@
           <a:lstStyle/>
           <a:p>
             <a:pPr algn="ctr"/>
+            <a:endParaRPr/>
           </a:p>
         </p:txBody>
       </p:sp>
@@ -8604,7 +9290,7 @@
           <a:noFill/>
         </p:spPr>
         <p:txBody>
-          <a:bodyPr wrap="square" anchor="t" lIns="0" rIns="0" tIns="0" bIns="0">
+          <a:bodyPr wrap="square" lIns="0" tIns="0" rIns="0" bIns="0" anchor="t">
             <a:spAutoFit/>
           </a:bodyPr>
           <a:lstStyle/>
@@ -8647,7 +9333,7 @@
           <a:noFill/>
         </p:spPr>
         <p:txBody>
-          <a:bodyPr wrap="square" anchor="t" lIns="0" rIns="0" tIns="0" bIns="0">
+          <a:bodyPr wrap="square" lIns="0" tIns="0" rIns="0" bIns="0" anchor="t">
             <a:spAutoFit/>
           </a:bodyPr>
           <a:lstStyle/>
@@ -8674,7 +9360,7 @@
 </file>
 
 <file path=ppt/slides/slide20.xml><?xml version="1.0" encoding="utf-8"?>
-<p:sld xmlns:a="http://schemas.openxmlformats.org/drawingml/2006/main" xmlns:p="http://schemas.openxmlformats.org/presentationml/2006/main" xmlns:r="http://schemas.openxmlformats.org/officeDocument/2006/relationships">
+<p:sld xmlns:a="http://schemas.openxmlformats.org/drawingml/2006/main" xmlns:r="http://schemas.openxmlformats.org/officeDocument/2006/relationships" xmlns:p="http://schemas.openxmlformats.org/presentationml/2006/main">
   <p:cSld>
     <p:bg>
       <p:bgPr>
@@ -8690,7 +9376,14 @@
         <p:cNvGrpSpPr/>
         <p:nvPr/>
       </p:nvGrpSpPr>
-      <p:grpSpPr/>
+      <p:grpSpPr>
+        <a:xfrm>
+          <a:off x="0" y="0"/>
+          <a:ext cx="0" cy="0"/>
+          <a:chOff x="0" y="0"/>
+          <a:chExt cx="0" cy="0"/>
+        </a:xfrm>
+      </p:grpSpPr>
       <p:sp>
         <p:nvSpPr>
           <p:cNvPr id="2" name="Rectangle 1"/>
@@ -8732,6 +9425,7 @@
           <a:lstStyle/>
           <a:p>
             <a:pPr algn="ctr"/>
+            <a:endParaRPr/>
           </a:p>
         </p:txBody>
       </p:sp>
@@ -8752,7 +9446,7 @@
           <a:noFill/>
         </p:spPr>
         <p:txBody>
-          <a:bodyPr wrap="square" anchor="t" lIns="0" rIns="0" tIns="0" bIns="0">
+          <a:bodyPr wrap="square" lIns="0" tIns="0" rIns="0" bIns="0" anchor="t">
             <a:spAutoFit/>
           </a:bodyPr>
           <a:lstStyle/>
@@ -8786,7 +9480,7 @@
           <a:noFill/>
         </p:spPr>
         <p:txBody>
-          <a:bodyPr wrap="square" anchor="t" lIns="0" rIns="0" tIns="0" bIns="0">
+          <a:bodyPr wrap="square" lIns="0" tIns="0" rIns="0" bIns="0" anchor="t">
             <a:spAutoFit/>
           </a:bodyPr>
           <a:lstStyle/>
@@ -8876,6 +9570,7 @@
           <a:lstStyle/>
           <a:p>
             <a:pPr algn="ctr"/>
+            <a:endParaRPr/>
           </a:p>
         </p:txBody>
       </p:sp>
@@ -8896,7 +9591,7 @@
           <a:noFill/>
         </p:spPr>
         <p:txBody>
-          <a:bodyPr wrap="square" anchor="t" lIns="0" rIns="0" tIns="0" bIns="0">
+          <a:bodyPr wrap="square" lIns="0" tIns="0" rIns="0" bIns="0" anchor="t">
             <a:spAutoFit/>
           </a:bodyPr>
           <a:lstStyle/>
@@ -8939,21 +9634,13 @@
           <a:noFill/>
         </p:spPr>
         <p:txBody>
-          <a:bodyPr wrap="square" anchor="t" lIns="0" rIns="0" tIns="0" bIns="0">
+          <a:bodyPr wrap="square" lIns="0" tIns="0" rIns="0" bIns="0" anchor="t">
             <a:spAutoFit/>
           </a:bodyPr>
           <a:lstStyle/>
           <a:p>
             <a:pPr algn="r"/>
-            <a:r>
-              <a:rPr sz="1100" b="0" i="0">
-                <a:solidFill>
-                  <a:srgbClr val="7A7A7A"/>
-                </a:solidFill>
-                <a:latin typeface="Roboto"/>
-              </a:rPr>
-              <a:t/>
-            </a:r>
+            <a:endParaRPr/>
           </a:p>
         </p:txBody>
       </p:sp>
@@ -8966,7 +9653,7 @@
 </file>
 
 <file path=ppt/slides/slide21.xml><?xml version="1.0" encoding="utf-8"?>
-<p:sld xmlns:a="http://schemas.openxmlformats.org/drawingml/2006/main" xmlns:p="http://schemas.openxmlformats.org/presentationml/2006/main" xmlns:r="http://schemas.openxmlformats.org/officeDocument/2006/relationships">
+<p:sld xmlns:a="http://schemas.openxmlformats.org/drawingml/2006/main" xmlns:r="http://schemas.openxmlformats.org/officeDocument/2006/relationships" xmlns:p="http://schemas.openxmlformats.org/presentationml/2006/main">
   <p:cSld>
     <p:bg>
       <p:bgPr>
@@ -8982,7 +9669,14 @@
         <p:cNvGrpSpPr/>
         <p:nvPr/>
       </p:nvGrpSpPr>
-      <p:grpSpPr/>
+      <p:grpSpPr>
+        <a:xfrm>
+          <a:off x="0" y="0"/>
+          <a:ext cx="0" cy="0"/>
+          <a:chOff x="0" y="0"/>
+          <a:chExt cx="0" cy="0"/>
+        </a:xfrm>
+      </p:grpSpPr>
       <p:sp>
         <p:nvSpPr>
           <p:cNvPr id="2" name="TextBox 1"/>
@@ -9000,7 +9694,7 @@
           <a:noFill/>
         </p:spPr>
         <p:txBody>
-          <a:bodyPr wrap="square" anchor="t" lIns="0" rIns="0" tIns="0" bIns="0">
+          <a:bodyPr wrap="square" lIns="0" tIns="0" rIns="0" bIns="0" anchor="t">
             <a:spAutoFit/>
           </a:bodyPr>
           <a:lstStyle/>
@@ -9058,6 +9752,7 @@
           <a:lstStyle/>
           <a:p>
             <a:pPr algn="ctr"/>
+            <a:endParaRPr/>
           </a:p>
         </p:txBody>
       </p:sp>
@@ -9078,7 +9773,7 @@
           <a:noFill/>
         </p:spPr>
         <p:txBody>
-          <a:bodyPr wrap="square" anchor="t" lIns="0" rIns="0" tIns="0" bIns="0">
+          <a:bodyPr wrap="square" lIns="0" tIns="0" rIns="0" bIns="0" anchor="t">
             <a:spAutoFit/>
           </a:bodyPr>
           <a:lstStyle/>
@@ -9218,6 +9913,7 @@
           <a:lstStyle/>
           <a:p>
             <a:pPr algn="ctr"/>
+            <a:endParaRPr/>
           </a:p>
         </p:txBody>
       </p:sp>
@@ -9238,7 +9934,7 @@
           <a:noFill/>
         </p:spPr>
         <p:txBody>
-          <a:bodyPr wrap="square" anchor="t" lIns="0" rIns="0" tIns="0" bIns="0">
+          <a:bodyPr wrap="square" lIns="0" tIns="0" rIns="0" bIns="0" anchor="t">
             <a:spAutoFit/>
           </a:bodyPr>
           <a:lstStyle/>
@@ -9281,7 +9977,7 @@
           <a:noFill/>
         </p:spPr>
         <p:txBody>
-          <a:bodyPr wrap="square" anchor="t" lIns="0" rIns="0" tIns="0" bIns="0">
+          <a:bodyPr wrap="square" lIns="0" tIns="0" rIns="0" bIns="0" anchor="t">
             <a:spAutoFit/>
           </a:bodyPr>
           <a:lstStyle/>
@@ -9308,7 +10004,7 @@
 </file>
 
 <file path=ppt/slides/slide22.xml><?xml version="1.0" encoding="utf-8"?>
-<p:sld xmlns:a="http://schemas.openxmlformats.org/drawingml/2006/main" xmlns:p="http://schemas.openxmlformats.org/presentationml/2006/main" xmlns:r="http://schemas.openxmlformats.org/officeDocument/2006/relationships">
+<p:sld xmlns:a="http://schemas.openxmlformats.org/drawingml/2006/main" xmlns:r="http://schemas.openxmlformats.org/officeDocument/2006/relationships" xmlns:p="http://schemas.openxmlformats.org/presentationml/2006/main">
   <p:cSld>
     <p:bg>
       <p:bgPr>
@@ -9324,7 +10020,14 @@
         <p:cNvGrpSpPr/>
         <p:nvPr/>
       </p:nvGrpSpPr>
-      <p:grpSpPr/>
+      <p:grpSpPr>
+        <a:xfrm>
+          <a:off x="0" y="0"/>
+          <a:ext cx="0" cy="0"/>
+          <a:chOff x="0" y="0"/>
+          <a:chExt cx="0" cy="0"/>
+        </a:xfrm>
+      </p:grpSpPr>
       <p:sp>
         <p:nvSpPr>
           <p:cNvPr id="2" name="TextBox 1"/>
@@ -9342,7 +10045,7 @@
           <a:noFill/>
         </p:spPr>
         <p:txBody>
-          <a:bodyPr wrap="square" anchor="t" lIns="0" rIns="0" tIns="0" bIns="0">
+          <a:bodyPr wrap="square" lIns="0" tIns="0" rIns="0" bIns="0" anchor="t">
             <a:spAutoFit/>
           </a:bodyPr>
           <a:lstStyle/>
@@ -9416,6 +10119,7 @@
           <a:lstStyle/>
           <a:p>
             <a:pPr algn="ctr"/>
+            <a:endParaRPr/>
           </a:p>
         </p:txBody>
       </p:sp>
@@ -9436,7 +10140,7 @@
           <a:noFill/>
         </p:spPr>
         <p:txBody>
-          <a:bodyPr wrap="square" anchor="t" lIns="0" rIns="0" tIns="0" bIns="0">
+          <a:bodyPr wrap="square" lIns="0" tIns="0" rIns="0" bIns="0" anchor="t">
             <a:spAutoFit/>
           </a:bodyPr>
           <a:lstStyle/>
@@ -9552,16 +10256,7 @@
                 </a:solidFill>
                 <a:latin typeface="Roboto"/>
               </a:rPr>
-              <a:t>■  </a:t>
-            </a:r>
-            <a:r>
-              <a:rPr sz="1800" b="1" i="0">
-                <a:solidFill>
-                  <a:srgbClr val="205F61"/>
-                </a:solidFill>
-                <a:latin typeface="Roboto"/>
-              </a:rPr>
-              <a:t>The cheaper option may carry the bigger intangible cost.</a:t>
+              <a:t>■  The cheaper option may carry the bigger intangible cost.</a:t>
             </a:r>
           </a:p>
         </p:txBody>
@@ -9607,6 +10302,7 @@
           <a:lstStyle/>
           <a:p>
             <a:pPr algn="ctr"/>
+            <a:endParaRPr/>
           </a:p>
         </p:txBody>
       </p:sp>
@@ -9627,7 +10323,7 @@
           <a:noFill/>
         </p:spPr>
         <p:txBody>
-          <a:bodyPr wrap="square" anchor="t" lIns="0" rIns="0" tIns="0" bIns="0">
+          <a:bodyPr wrap="square" lIns="0" tIns="0" rIns="0" bIns="0" anchor="t">
             <a:spAutoFit/>
           </a:bodyPr>
           <a:lstStyle/>
@@ -9670,7 +10366,7 @@
           <a:noFill/>
         </p:spPr>
         <p:txBody>
-          <a:bodyPr wrap="square" anchor="t" lIns="0" rIns="0" tIns="0" bIns="0">
+          <a:bodyPr wrap="square" lIns="0" tIns="0" rIns="0" bIns="0" anchor="t">
             <a:spAutoFit/>
           </a:bodyPr>
           <a:lstStyle/>
@@ -9697,7 +10393,7 @@
 </file>
 
 <file path=ppt/slides/slide23.xml><?xml version="1.0" encoding="utf-8"?>
-<p:sld xmlns:a="http://schemas.openxmlformats.org/drawingml/2006/main" xmlns:p="http://schemas.openxmlformats.org/presentationml/2006/main" xmlns:r="http://schemas.openxmlformats.org/officeDocument/2006/relationships">
+<p:sld xmlns:a="http://schemas.openxmlformats.org/drawingml/2006/main" xmlns:r="http://schemas.openxmlformats.org/officeDocument/2006/relationships" xmlns:p="http://schemas.openxmlformats.org/presentationml/2006/main">
   <p:cSld>
     <p:bg>
       <p:bgPr>
@@ -9713,7 +10409,14 @@
         <p:cNvGrpSpPr/>
         <p:nvPr/>
       </p:nvGrpSpPr>
-      <p:grpSpPr/>
+      <p:grpSpPr>
+        <a:xfrm>
+          <a:off x="0" y="0"/>
+          <a:ext cx="0" cy="0"/>
+          <a:chOff x="0" y="0"/>
+          <a:chExt cx="0" cy="0"/>
+        </a:xfrm>
+      </p:grpSpPr>
       <p:sp>
         <p:nvSpPr>
           <p:cNvPr id="2" name="TextBox 1"/>
@@ -9731,7 +10434,7 @@
           <a:noFill/>
         </p:spPr>
         <p:txBody>
-          <a:bodyPr wrap="square" anchor="t" lIns="0" rIns="0" tIns="0" bIns="0">
+          <a:bodyPr wrap="square" lIns="0" tIns="0" rIns="0" bIns="0" anchor="t">
             <a:spAutoFit/>
           </a:bodyPr>
           <a:lstStyle/>
@@ -9789,6 +10492,7 @@
           <a:lstStyle/>
           <a:p>
             <a:pPr algn="ctr"/>
+            <a:endParaRPr/>
           </a:p>
         </p:txBody>
       </p:sp>
@@ -9809,7 +10513,7 @@
           <a:noFill/>
         </p:spPr>
         <p:txBody>
-          <a:bodyPr wrap="square" anchor="t" lIns="0" rIns="0" tIns="0" bIns="0">
+          <a:bodyPr wrap="square" lIns="0" tIns="0" rIns="0" bIns="0" anchor="t">
             <a:spAutoFit/>
           </a:bodyPr>
           <a:lstStyle/>
@@ -9925,16 +10629,7 @@
                 </a:solidFill>
                 <a:latin typeface="Roboto"/>
               </a:rPr>
-              <a:t>■  </a:t>
-            </a:r>
-            <a:r>
-              <a:rPr sz="1800" b="1" i="0">
-                <a:solidFill>
-                  <a:srgbClr val="205F61"/>
-                </a:solidFill>
-                <a:latin typeface="Roboto"/>
-              </a:rPr>
-              <a:t>A risk with no mitigation is just a worry; a mitigation makes it manageable.</a:t>
+              <a:t>■  A risk with no mitigation is just a worry; a mitigation makes it manageable.</a:t>
             </a:r>
           </a:p>
         </p:txBody>
@@ -9980,6 +10675,7 @@
           <a:lstStyle/>
           <a:p>
             <a:pPr algn="ctr"/>
+            <a:endParaRPr/>
           </a:p>
         </p:txBody>
       </p:sp>
@@ -10000,7 +10696,7 @@
           <a:noFill/>
         </p:spPr>
         <p:txBody>
-          <a:bodyPr wrap="square" anchor="t" lIns="0" rIns="0" tIns="0" bIns="0">
+          <a:bodyPr wrap="square" lIns="0" tIns="0" rIns="0" bIns="0" anchor="t">
             <a:spAutoFit/>
           </a:bodyPr>
           <a:lstStyle/>
@@ -10043,7 +10739,7 @@
           <a:noFill/>
         </p:spPr>
         <p:txBody>
-          <a:bodyPr wrap="square" anchor="t" lIns="0" rIns="0" tIns="0" bIns="0">
+          <a:bodyPr wrap="square" lIns="0" tIns="0" rIns="0" bIns="0" anchor="t">
             <a:spAutoFit/>
           </a:bodyPr>
           <a:lstStyle/>
@@ -10070,7 +10766,7 @@
 </file>
 
 <file path=ppt/slides/slide24.xml><?xml version="1.0" encoding="utf-8"?>
-<p:sld xmlns:a="http://schemas.openxmlformats.org/drawingml/2006/main" xmlns:p="http://schemas.openxmlformats.org/presentationml/2006/main" xmlns:r="http://schemas.openxmlformats.org/officeDocument/2006/relationships">
+<p:sld xmlns:a="http://schemas.openxmlformats.org/drawingml/2006/main" xmlns:r="http://schemas.openxmlformats.org/officeDocument/2006/relationships" xmlns:p="http://schemas.openxmlformats.org/presentationml/2006/main">
   <p:cSld>
     <p:bg>
       <p:bgPr>
@@ -10086,7 +10782,14 @@
         <p:cNvGrpSpPr/>
         <p:nvPr/>
       </p:nvGrpSpPr>
-      <p:grpSpPr/>
+      <p:grpSpPr>
+        <a:xfrm>
+          <a:off x="0" y="0"/>
+          <a:ext cx="0" cy="0"/>
+          <a:chOff x="0" y="0"/>
+          <a:chExt cx="0" cy="0"/>
+        </a:xfrm>
+      </p:grpSpPr>
       <p:sp>
         <p:nvSpPr>
           <p:cNvPr id="2" name="Rectangle 1"/>
@@ -10128,6 +10831,7 @@
           <a:lstStyle/>
           <a:p>
             <a:pPr algn="ctr"/>
+            <a:endParaRPr/>
           </a:p>
         </p:txBody>
       </p:sp>
@@ -10168,7 +10872,7 @@
           </a:fontRef>
         </p:style>
         <p:txBody>
-          <a:bodyPr rtlCol="0" anchor="ctr" wrap="none"/>
+          <a:bodyPr wrap="none" rtlCol="0" anchor="ctr"/>
           <a:lstStyle/>
           <a:p>
             <a:pPr algn="ctr"/>
@@ -10201,7 +10905,7 @@
           <a:noFill/>
         </p:spPr>
         <p:txBody>
-          <a:bodyPr wrap="square" anchor="ctr" lIns="0" rIns="0" tIns="0" bIns="0">
+          <a:bodyPr wrap="square" lIns="0" tIns="0" rIns="0" bIns="0" anchor="ctr">
             <a:spAutoFit/>
           </a:bodyPr>
           <a:lstStyle/>
@@ -10235,7 +10939,7 @@
           <a:noFill/>
         </p:spPr>
         <p:txBody>
-          <a:bodyPr wrap="square" anchor="t" lIns="0" rIns="0" tIns="0" bIns="0">
+          <a:bodyPr wrap="square" lIns="0" tIns="0" rIns="0" bIns="0" anchor="t">
             <a:spAutoFit/>
           </a:bodyPr>
           <a:lstStyle/>
@@ -10470,6 +11174,7 @@
           <a:lstStyle/>
           <a:p>
             <a:pPr algn="ctr"/>
+            <a:endParaRPr/>
           </a:p>
         </p:txBody>
       </p:sp>
@@ -10490,7 +11195,7 @@
           <a:noFill/>
         </p:spPr>
         <p:txBody>
-          <a:bodyPr wrap="square" anchor="ctr" lIns="0" rIns="0" tIns="0" bIns="0">
+          <a:bodyPr wrap="square" lIns="0" tIns="0" rIns="0" bIns="0" anchor="ctr">
             <a:spAutoFit/>
           </a:bodyPr>
           <a:lstStyle/>
@@ -10548,6 +11253,7 @@
           <a:lstStyle/>
           <a:p>
             <a:pPr algn="ctr"/>
+            <a:endParaRPr/>
           </a:p>
         </p:txBody>
       </p:sp>
@@ -10568,7 +11274,7 @@
           <a:noFill/>
         </p:spPr>
         <p:txBody>
-          <a:bodyPr wrap="square" anchor="t" lIns="0" rIns="0" tIns="0" bIns="0">
+          <a:bodyPr wrap="square" lIns="0" tIns="0" rIns="0" bIns="0" anchor="t">
             <a:spAutoFit/>
           </a:bodyPr>
           <a:lstStyle/>
@@ -10611,7 +11317,7 @@
           <a:noFill/>
         </p:spPr>
         <p:txBody>
-          <a:bodyPr wrap="square" anchor="t" lIns="0" rIns="0" tIns="0" bIns="0">
+          <a:bodyPr wrap="square" lIns="0" tIns="0" rIns="0" bIns="0" anchor="t">
             <a:spAutoFit/>
           </a:bodyPr>
           <a:lstStyle/>
@@ -10638,7 +11344,7 @@
 </file>
 
 <file path=ppt/slides/slide25.xml><?xml version="1.0" encoding="utf-8"?>
-<p:sld xmlns:a="http://schemas.openxmlformats.org/drawingml/2006/main" xmlns:p="http://schemas.openxmlformats.org/presentationml/2006/main" xmlns:r="http://schemas.openxmlformats.org/officeDocument/2006/relationships">
+<p:sld xmlns:a="http://schemas.openxmlformats.org/drawingml/2006/main" xmlns:r="http://schemas.openxmlformats.org/officeDocument/2006/relationships" xmlns:p="http://schemas.openxmlformats.org/presentationml/2006/main">
   <p:cSld>
     <p:bg>
       <p:bgPr>
@@ -10654,7 +11360,14 @@
         <p:cNvGrpSpPr/>
         <p:nvPr/>
       </p:nvGrpSpPr>
-      <p:grpSpPr/>
+      <p:grpSpPr>
+        <a:xfrm>
+          <a:off x="0" y="0"/>
+          <a:ext cx="0" cy="0"/>
+          <a:chOff x="0" y="0"/>
+          <a:chExt cx="0" cy="0"/>
+        </a:xfrm>
+      </p:grpSpPr>
       <p:sp>
         <p:nvSpPr>
           <p:cNvPr id="2" name="TextBox 1"/>
@@ -10672,7 +11385,7 @@
           <a:noFill/>
         </p:spPr>
         <p:txBody>
-          <a:bodyPr wrap="square" anchor="t" lIns="0" rIns="0" tIns="0" bIns="0">
+          <a:bodyPr wrap="square" lIns="0" tIns="0" rIns="0" bIns="0" anchor="t">
             <a:spAutoFit/>
           </a:bodyPr>
           <a:lstStyle/>
@@ -10746,6 +11459,7 @@
           <a:lstStyle/>
           <a:p>
             <a:pPr algn="ctr"/>
+            <a:endParaRPr/>
           </a:p>
         </p:txBody>
       </p:sp>
@@ -10792,6 +11506,7 @@
           <a:lstStyle/>
           <a:p>
             <a:pPr algn="ctr"/>
+            <a:endParaRPr/>
           </a:p>
         </p:txBody>
       </p:sp>
@@ -10836,6 +11551,7 @@
           <a:lstStyle/>
           <a:p>
             <a:pPr algn="ctr"/>
+            <a:endParaRPr/>
           </a:p>
         </p:txBody>
       </p:sp>
@@ -10856,7 +11572,7 @@
           <a:noFill/>
         </p:spPr>
         <p:txBody>
-          <a:bodyPr wrap="square" anchor="ctr" lIns="0" rIns="0" tIns="0" bIns="0">
+          <a:bodyPr wrap="square" lIns="0" tIns="0" rIns="0" bIns="0" anchor="ctr">
             <a:spAutoFit/>
           </a:bodyPr>
           <a:lstStyle/>
@@ -10921,6 +11637,7 @@
           <a:lstStyle/>
           <a:p>
             <a:pPr algn="ctr"/>
+            <a:endParaRPr/>
           </a:p>
         </p:txBody>
       </p:sp>
@@ -10965,6 +11682,7 @@
           <a:lstStyle/>
           <a:p>
             <a:pPr algn="ctr"/>
+            <a:endParaRPr/>
           </a:p>
         </p:txBody>
       </p:sp>
@@ -10985,7 +11703,7 @@
           <a:noFill/>
         </p:spPr>
         <p:txBody>
-          <a:bodyPr wrap="square" anchor="ctr" lIns="0" rIns="0" tIns="0" bIns="0">
+          <a:bodyPr wrap="square" lIns="0" tIns="0" rIns="0" bIns="0" anchor="ctr">
             <a:spAutoFit/>
           </a:bodyPr>
           <a:lstStyle/>
@@ -11050,6 +11768,7 @@
           <a:lstStyle/>
           <a:p>
             <a:pPr algn="ctr"/>
+            <a:endParaRPr/>
           </a:p>
         </p:txBody>
       </p:sp>
@@ -11094,6 +11813,7 @@
           <a:lstStyle/>
           <a:p>
             <a:pPr algn="ctr"/>
+            <a:endParaRPr/>
           </a:p>
         </p:txBody>
       </p:sp>
@@ -11114,7 +11834,7 @@
           <a:noFill/>
         </p:spPr>
         <p:txBody>
-          <a:bodyPr wrap="square" anchor="ctr" lIns="0" rIns="0" tIns="0" bIns="0">
+          <a:bodyPr wrap="square" lIns="0" tIns="0" rIns="0" bIns="0" anchor="ctr">
             <a:spAutoFit/>
           </a:bodyPr>
           <a:lstStyle/>
@@ -11177,6 +11897,7 @@
           <a:lstStyle/>
           <a:p>
             <a:pPr algn="ctr"/>
+            <a:endParaRPr/>
           </a:p>
         </p:txBody>
       </p:sp>
@@ -11197,7 +11918,7 @@
           <a:noFill/>
         </p:spPr>
         <p:txBody>
-          <a:bodyPr wrap="square" anchor="t" lIns="0" rIns="0" tIns="0" bIns="0">
+          <a:bodyPr wrap="square" lIns="0" tIns="0" rIns="0" bIns="0" anchor="t">
             <a:spAutoFit/>
           </a:bodyPr>
           <a:lstStyle/>
@@ -11240,7 +11961,7 @@
           <a:noFill/>
         </p:spPr>
         <p:txBody>
-          <a:bodyPr wrap="square" anchor="t" lIns="0" rIns="0" tIns="0" bIns="0">
+          <a:bodyPr wrap="square" lIns="0" tIns="0" rIns="0" bIns="0" anchor="t">
             <a:spAutoFit/>
           </a:bodyPr>
           <a:lstStyle/>
@@ -11267,7 +11988,7 @@
 </file>
 
 <file path=ppt/slides/slide26.xml><?xml version="1.0" encoding="utf-8"?>
-<p:sld xmlns:a="http://schemas.openxmlformats.org/drawingml/2006/main" xmlns:p="http://schemas.openxmlformats.org/presentationml/2006/main" xmlns:r="http://schemas.openxmlformats.org/officeDocument/2006/relationships">
+<p:sld xmlns:a="http://schemas.openxmlformats.org/drawingml/2006/main" xmlns:r="http://schemas.openxmlformats.org/officeDocument/2006/relationships" xmlns:p="http://schemas.openxmlformats.org/presentationml/2006/main">
   <p:cSld>
     <p:bg>
       <p:bgPr>
@@ -11283,7 +12004,14 @@
         <p:cNvGrpSpPr/>
         <p:nvPr/>
       </p:nvGrpSpPr>
-      <p:grpSpPr/>
+      <p:grpSpPr>
+        <a:xfrm>
+          <a:off x="0" y="0"/>
+          <a:ext cx="0" cy="0"/>
+          <a:chOff x="0" y="0"/>
+          <a:chExt cx="0" cy="0"/>
+        </a:xfrm>
+      </p:grpSpPr>
       <p:sp>
         <p:nvSpPr>
           <p:cNvPr id="2" name="Rectangle 1"/>
@@ -11325,6 +12053,7 @@
           <a:lstStyle/>
           <a:p>
             <a:pPr algn="ctr"/>
+            <a:endParaRPr/>
           </a:p>
         </p:txBody>
       </p:sp>
@@ -11345,7 +12074,7 @@
           <a:noFill/>
         </p:spPr>
         <p:txBody>
-          <a:bodyPr wrap="square" anchor="t" lIns="0" rIns="0" tIns="0" bIns="0">
+          <a:bodyPr wrap="square" lIns="0" tIns="0" rIns="0" bIns="0" anchor="t">
             <a:spAutoFit/>
           </a:bodyPr>
           <a:lstStyle/>
@@ -11447,7 +12176,7 @@
 </file>
 
 <file path=ppt/slides/slide3.xml><?xml version="1.0" encoding="utf-8"?>
-<p:sld xmlns:a="http://schemas.openxmlformats.org/drawingml/2006/main" xmlns:p="http://schemas.openxmlformats.org/presentationml/2006/main" xmlns:r="http://schemas.openxmlformats.org/officeDocument/2006/relationships">
+<p:sld xmlns:a="http://schemas.openxmlformats.org/drawingml/2006/main" xmlns:r="http://schemas.openxmlformats.org/officeDocument/2006/relationships" xmlns:p="http://schemas.openxmlformats.org/presentationml/2006/main">
   <p:cSld>
     <p:bg>
       <p:bgPr>
@@ -11463,7 +12192,14 @@
         <p:cNvGrpSpPr/>
         <p:nvPr/>
       </p:nvGrpSpPr>
-      <p:grpSpPr/>
+      <p:grpSpPr>
+        <a:xfrm>
+          <a:off x="0" y="0"/>
+          <a:ext cx="0" cy="0"/>
+          <a:chOff x="0" y="0"/>
+          <a:chExt cx="0" cy="0"/>
+        </a:xfrm>
+      </p:grpSpPr>
       <p:sp>
         <p:nvSpPr>
           <p:cNvPr id="2" name="Rectangle 1"/>
@@ -11505,6 +12241,7 @@
           <a:lstStyle/>
           <a:p>
             <a:pPr algn="ctr"/>
+            <a:endParaRPr/>
           </a:p>
         </p:txBody>
       </p:sp>
@@ -11525,7 +12262,7 @@
           <a:noFill/>
         </p:spPr>
         <p:txBody>
-          <a:bodyPr wrap="square" anchor="t" lIns="0" rIns="0" tIns="0" bIns="0">
+          <a:bodyPr wrap="square" lIns="0" tIns="0" rIns="0" bIns="0" anchor="t">
             <a:spAutoFit/>
           </a:bodyPr>
           <a:lstStyle/>
@@ -11559,7 +12296,7 @@
           <a:noFill/>
         </p:spPr>
         <p:txBody>
-          <a:bodyPr wrap="square" anchor="t" lIns="0" rIns="0" tIns="0" bIns="0">
+          <a:bodyPr wrap="square" lIns="0" tIns="0" rIns="0" bIns="0" anchor="t">
             <a:spAutoFit/>
           </a:bodyPr>
           <a:lstStyle/>
@@ -11649,6 +12386,7 @@
           <a:lstStyle/>
           <a:p>
             <a:pPr algn="ctr"/>
+            <a:endParaRPr/>
           </a:p>
         </p:txBody>
       </p:sp>
@@ -11669,7 +12407,7 @@
           <a:noFill/>
         </p:spPr>
         <p:txBody>
-          <a:bodyPr wrap="square" anchor="t" lIns="0" rIns="0" tIns="0" bIns="0">
+          <a:bodyPr wrap="square" lIns="0" tIns="0" rIns="0" bIns="0" anchor="t">
             <a:spAutoFit/>
           </a:bodyPr>
           <a:lstStyle/>
@@ -11712,21 +12450,13 @@
           <a:noFill/>
         </p:spPr>
         <p:txBody>
-          <a:bodyPr wrap="square" anchor="t" lIns="0" rIns="0" tIns="0" bIns="0">
+          <a:bodyPr wrap="square" lIns="0" tIns="0" rIns="0" bIns="0" anchor="t">
             <a:spAutoFit/>
           </a:bodyPr>
           <a:lstStyle/>
           <a:p>
             <a:pPr algn="r"/>
-            <a:r>
-              <a:rPr sz="1100" b="0" i="0">
-                <a:solidFill>
-                  <a:srgbClr val="7A7A7A"/>
-                </a:solidFill>
-                <a:latin typeface="Roboto"/>
-              </a:rPr>
-              <a:t/>
-            </a:r>
+            <a:endParaRPr/>
           </a:p>
         </p:txBody>
       </p:sp>
@@ -11739,7 +12469,7 @@
 </file>
 
 <file path=ppt/slides/slide4.xml><?xml version="1.0" encoding="utf-8"?>
-<p:sld xmlns:a="http://schemas.openxmlformats.org/drawingml/2006/main" xmlns:p="http://schemas.openxmlformats.org/presentationml/2006/main" xmlns:r="http://schemas.openxmlformats.org/officeDocument/2006/relationships">
+<p:sld xmlns:a="http://schemas.openxmlformats.org/drawingml/2006/main" xmlns:r="http://schemas.openxmlformats.org/officeDocument/2006/relationships" xmlns:p="http://schemas.openxmlformats.org/presentationml/2006/main">
   <p:cSld>
     <p:bg>
       <p:bgPr>
@@ -11755,7 +12485,14 @@
         <p:cNvGrpSpPr/>
         <p:nvPr/>
       </p:nvGrpSpPr>
-      <p:grpSpPr/>
+      <p:grpSpPr>
+        <a:xfrm>
+          <a:off x="0" y="0"/>
+          <a:ext cx="0" cy="0"/>
+          <a:chOff x="0" y="0"/>
+          <a:chExt cx="0" cy="0"/>
+        </a:xfrm>
+      </p:grpSpPr>
       <p:sp>
         <p:nvSpPr>
           <p:cNvPr id="2" name="TextBox 1"/>
@@ -11773,7 +12510,7 @@
           <a:noFill/>
         </p:spPr>
         <p:txBody>
-          <a:bodyPr wrap="square" anchor="t" lIns="0" rIns="0" tIns="0" bIns="0">
+          <a:bodyPr wrap="square" lIns="0" tIns="0" rIns="0" bIns="0" anchor="t">
             <a:spAutoFit/>
           </a:bodyPr>
           <a:lstStyle/>
@@ -11831,6 +12568,7 @@
           <a:lstStyle/>
           <a:p>
             <a:pPr algn="ctr"/>
+            <a:endParaRPr/>
           </a:p>
         </p:txBody>
       </p:sp>
@@ -11851,7 +12589,7 @@
           <a:noFill/>
         </p:spPr>
         <p:txBody>
-          <a:bodyPr wrap="square" anchor="t" lIns="0" rIns="0" tIns="0" bIns="0">
+          <a:bodyPr wrap="square" lIns="0" tIns="0" rIns="0" bIns="0" anchor="t">
             <a:spAutoFit/>
           </a:bodyPr>
           <a:lstStyle/>
@@ -11936,16 +12674,7 @@
                 </a:solidFill>
                 <a:latin typeface="Roboto"/>
               </a:rPr>
-              <a:t>■  </a:t>
-            </a:r>
-            <a:r>
-              <a:rPr sz="1800" b="1" i="0">
-                <a:solidFill>
-                  <a:srgbClr val="92268F"/>
-                </a:solidFill>
-                <a:latin typeface="Roboto"/>
-              </a:rPr>
-              <a:t>Your job here: lay the options out and evaluate them — not pick one.</a:t>
+              <a:t>■  Your job here: lay the options out and evaluate them — not pick one.</a:t>
             </a:r>
           </a:p>
         </p:txBody>
@@ -11991,6 +12720,7 @@
           <a:lstStyle/>
           <a:p>
             <a:pPr algn="ctr"/>
+            <a:endParaRPr/>
           </a:p>
         </p:txBody>
       </p:sp>
@@ -12011,7 +12741,7 @@
           <a:noFill/>
         </p:spPr>
         <p:txBody>
-          <a:bodyPr wrap="square" anchor="t" lIns="0" rIns="0" tIns="0" bIns="0">
+          <a:bodyPr wrap="square" lIns="0" tIns="0" rIns="0" bIns="0" anchor="t">
             <a:spAutoFit/>
           </a:bodyPr>
           <a:lstStyle/>
@@ -12054,7 +12784,7 @@
           <a:noFill/>
         </p:spPr>
         <p:txBody>
-          <a:bodyPr wrap="square" anchor="t" lIns="0" rIns="0" tIns="0" bIns="0">
+          <a:bodyPr wrap="square" lIns="0" tIns="0" rIns="0" bIns="0" anchor="t">
             <a:spAutoFit/>
           </a:bodyPr>
           <a:lstStyle/>
@@ -12081,7 +12811,7 @@
 </file>
 
 <file path=ppt/slides/slide5.xml><?xml version="1.0" encoding="utf-8"?>
-<p:sld xmlns:a="http://schemas.openxmlformats.org/drawingml/2006/main" xmlns:p="http://schemas.openxmlformats.org/presentationml/2006/main" xmlns:r="http://schemas.openxmlformats.org/officeDocument/2006/relationships">
+<p:sld xmlns:a="http://schemas.openxmlformats.org/drawingml/2006/main" xmlns:r="http://schemas.openxmlformats.org/officeDocument/2006/relationships" xmlns:p="http://schemas.openxmlformats.org/presentationml/2006/main">
   <p:cSld>
     <p:bg>
       <p:bgPr>
@@ -12097,7 +12827,14 @@
         <p:cNvGrpSpPr/>
         <p:nvPr/>
       </p:nvGrpSpPr>
-      <p:grpSpPr/>
+      <p:grpSpPr>
+        <a:xfrm>
+          <a:off x="0" y="0"/>
+          <a:ext cx="0" cy="0"/>
+          <a:chOff x="0" y="0"/>
+          <a:chExt cx="0" cy="0"/>
+        </a:xfrm>
+      </p:grpSpPr>
       <p:sp>
         <p:nvSpPr>
           <p:cNvPr id="2" name="TextBox 1"/>
@@ -12115,7 +12852,7 @@
           <a:noFill/>
         </p:spPr>
         <p:txBody>
-          <a:bodyPr wrap="square" anchor="t" lIns="0" rIns="0" tIns="0" bIns="0">
+          <a:bodyPr wrap="square" lIns="0" tIns="0" rIns="0" bIns="0" anchor="t">
             <a:spAutoFit/>
           </a:bodyPr>
           <a:lstStyle/>
@@ -12189,6 +12926,7 @@
           <a:lstStyle/>
           <a:p>
             <a:pPr algn="ctr"/>
+            <a:endParaRPr/>
           </a:p>
         </p:txBody>
       </p:sp>
@@ -12209,7 +12947,7 @@
           <a:noFill/>
         </p:spPr>
         <p:txBody>
-          <a:bodyPr wrap="square" anchor="t" lIns="0" rIns="0" tIns="0" bIns="0">
+          <a:bodyPr wrap="square" lIns="0" tIns="0" rIns="0" bIns="0" anchor="t">
             <a:spAutoFit/>
           </a:bodyPr>
           <a:lstStyle/>
@@ -12325,16 +13063,7 @@
                 </a:solidFill>
                 <a:latin typeface="Roboto"/>
               </a:rPr>
-              <a:t>■  </a:t>
-            </a:r>
-            <a:r>
-              <a:rPr sz="1800" b="1" i="0">
-                <a:solidFill>
-                  <a:srgbClr val="92268F"/>
-                </a:solidFill>
-                <a:latin typeface="Roboto"/>
-              </a:rPr>
-              <a:t>Write it down first — it's the yardstick every option is measured against.</a:t>
+              <a:t>■  Write it down first — it's the yardstick every option is measured against.</a:t>
             </a:r>
           </a:p>
         </p:txBody>
@@ -12380,6 +13109,7 @@
           <a:lstStyle/>
           <a:p>
             <a:pPr algn="ctr"/>
+            <a:endParaRPr/>
           </a:p>
         </p:txBody>
       </p:sp>
@@ -12400,7 +13130,7 @@
           <a:noFill/>
         </p:spPr>
         <p:txBody>
-          <a:bodyPr wrap="square" anchor="t" lIns="0" rIns="0" tIns="0" bIns="0">
+          <a:bodyPr wrap="square" lIns="0" tIns="0" rIns="0" bIns="0" anchor="t">
             <a:spAutoFit/>
           </a:bodyPr>
           <a:lstStyle/>
@@ -12443,7 +13173,7 @@
           <a:noFill/>
         </p:spPr>
         <p:txBody>
-          <a:bodyPr wrap="square" anchor="t" lIns="0" rIns="0" tIns="0" bIns="0">
+          <a:bodyPr wrap="square" lIns="0" tIns="0" rIns="0" bIns="0" anchor="t">
             <a:spAutoFit/>
           </a:bodyPr>
           <a:lstStyle/>
@@ -12470,7 +13200,7 @@
 </file>
 
 <file path=ppt/slides/slide6.xml><?xml version="1.0" encoding="utf-8"?>
-<p:sld xmlns:a="http://schemas.openxmlformats.org/drawingml/2006/main" xmlns:p="http://schemas.openxmlformats.org/presentationml/2006/main" xmlns:r="http://schemas.openxmlformats.org/officeDocument/2006/relationships">
+<p:sld xmlns:a="http://schemas.openxmlformats.org/drawingml/2006/main" xmlns:r="http://schemas.openxmlformats.org/officeDocument/2006/relationships" xmlns:p="http://schemas.openxmlformats.org/presentationml/2006/main">
   <p:cSld>
     <p:bg>
       <p:bgPr>
@@ -12486,7 +13216,14 @@
         <p:cNvGrpSpPr/>
         <p:nvPr/>
       </p:nvGrpSpPr>
-      <p:grpSpPr/>
+      <p:grpSpPr>
+        <a:xfrm>
+          <a:off x="0" y="0"/>
+          <a:ext cx="0" cy="0"/>
+          <a:chOff x="0" y="0"/>
+          <a:chExt cx="0" cy="0"/>
+        </a:xfrm>
+      </p:grpSpPr>
       <p:sp>
         <p:nvSpPr>
           <p:cNvPr id="2" name="TextBox 1"/>
@@ -12504,7 +13241,7 @@
           <a:noFill/>
         </p:spPr>
         <p:txBody>
-          <a:bodyPr wrap="square" anchor="t" lIns="0" rIns="0" tIns="0" bIns="0">
+          <a:bodyPr wrap="square" lIns="0" tIns="0" rIns="0" bIns="0" anchor="t">
             <a:spAutoFit/>
           </a:bodyPr>
           <a:lstStyle/>
@@ -12562,6 +13299,7 @@
           <a:lstStyle/>
           <a:p>
             <a:pPr algn="ctr"/>
+            <a:endParaRPr/>
           </a:p>
         </p:txBody>
       </p:sp>
@@ -12582,7 +13320,7 @@
           <a:noFill/>
         </p:spPr>
         <p:txBody>
-          <a:bodyPr wrap="square" anchor="t" lIns="0" rIns="0" tIns="0" bIns="0">
+          <a:bodyPr wrap="square" lIns="0" tIns="0" rIns="0" bIns="0" anchor="t">
             <a:spAutoFit/>
           </a:bodyPr>
           <a:lstStyle/>
@@ -12729,16 +13467,7 @@
                 </a:solidFill>
                 <a:latin typeface="Roboto"/>
               </a:rPr>
-              <a:t>■  </a:t>
-            </a:r>
-            <a:r>
-              <a:rPr sz="1800" b="1" i="0">
-                <a:solidFill>
-                  <a:srgbClr val="92268F"/>
-                </a:solidFill>
-                <a:latin typeface="Roboto"/>
-              </a:rPr>
-              <a:t>Every comparison needs the status-quo option — or “moving” has nothing to beat.</a:t>
+              <a:t>■  Every comparison needs the status-quo option — or “moving” has nothing to beat.</a:t>
             </a:r>
           </a:p>
         </p:txBody>
@@ -12784,6 +13513,7 @@
           <a:lstStyle/>
           <a:p>
             <a:pPr algn="ctr"/>
+            <a:endParaRPr/>
           </a:p>
         </p:txBody>
       </p:sp>
@@ -12804,7 +13534,7 @@
           <a:noFill/>
         </p:spPr>
         <p:txBody>
-          <a:bodyPr wrap="square" anchor="t" lIns="0" rIns="0" tIns="0" bIns="0">
+          <a:bodyPr wrap="square" lIns="0" tIns="0" rIns="0" bIns="0" anchor="t">
             <a:spAutoFit/>
           </a:bodyPr>
           <a:lstStyle/>
@@ -12847,7 +13577,7 @@
           <a:noFill/>
         </p:spPr>
         <p:txBody>
-          <a:bodyPr wrap="square" anchor="t" lIns="0" rIns="0" tIns="0" bIns="0">
+          <a:bodyPr wrap="square" lIns="0" tIns="0" rIns="0" bIns="0" anchor="t">
             <a:spAutoFit/>
           </a:bodyPr>
           <a:lstStyle/>
@@ -12874,7 +13604,7 @@
 </file>
 
 <file path=ppt/slides/slide7.xml><?xml version="1.0" encoding="utf-8"?>
-<p:sld xmlns:a="http://schemas.openxmlformats.org/drawingml/2006/main" xmlns:p="http://schemas.openxmlformats.org/presentationml/2006/main" xmlns:r="http://schemas.openxmlformats.org/officeDocument/2006/relationships">
+<p:sld xmlns:a="http://schemas.openxmlformats.org/drawingml/2006/main" xmlns:r="http://schemas.openxmlformats.org/officeDocument/2006/relationships" xmlns:p="http://schemas.openxmlformats.org/presentationml/2006/main">
   <p:cSld>
     <p:bg>
       <p:bgPr>
@@ -12890,7 +13620,14 @@
         <p:cNvGrpSpPr/>
         <p:nvPr/>
       </p:nvGrpSpPr>
-      <p:grpSpPr/>
+      <p:grpSpPr>
+        <a:xfrm>
+          <a:off x="0" y="0"/>
+          <a:ext cx="0" cy="0"/>
+          <a:chOff x="0" y="0"/>
+          <a:chExt cx="0" cy="0"/>
+        </a:xfrm>
+      </p:grpSpPr>
       <p:sp>
         <p:nvSpPr>
           <p:cNvPr id="2" name="TextBox 1"/>
@@ -12908,7 +13645,7 @@
           <a:noFill/>
         </p:spPr>
         <p:txBody>
-          <a:bodyPr wrap="square" anchor="t" lIns="0" rIns="0" tIns="0" bIns="0">
+          <a:bodyPr wrap="square" lIns="0" tIns="0" rIns="0" bIns="0" anchor="t">
             <a:spAutoFit/>
           </a:bodyPr>
           <a:lstStyle/>
@@ -12982,6 +13719,7 @@
           <a:lstStyle/>
           <a:p>
             <a:pPr algn="ctr"/>
+            <a:endParaRPr/>
           </a:p>
         </p:txBody>
       </p:sp>
@@ -13002,7 +13740,7 @@
           <a:noFill/>
         </p:spPr>
         <p:txBody>
-          <a:bodyPr wrap="square" anchor="t" lIns="0" rIns="0" tIns="0" bIns="0">
+          <a:bodyPr wrap="square" lIns="0" tIns="0" rIns="0" bIns="0" anchor="t">
             <a:spAutoFit/>
           </a:bodyPr>
           <a:lstStyle/>
@@ -13173,6 +13911,7 @@
           <a:lstStyle/>
           <a:p>
             <a:pPr algn="ctr"/>
+            <a:endParaRPr/>
           </a:p>
         </p:txBody>
       </p:sp>
@@ -13193,7 +13932,7 @@
           <a:noFill/>
         </p:spPr>
         <p:txBody>
-          <a:bodyPr wrap="square" anchor="t" lIns="0" rIns="0" tIns="0" bIns="0">
+          <a:bodyPr wrap="square" lIns="0" tIns="0" rIns="0" bIns="0" anchor="t">
             <a:spAutoFit/>
           </a:bodyPr>
           <a:lstStyle/>
@@ -13236,7 +13975,7 @@
           <a:noFill/>
         </p:spPr>
         <p:txBody>
-          <a:bodyPr wrap="square" anchor="t" lIns="0" rIns="0" tIns="0" bIns="0">
+          <a:bodyPr wrap="square" lIns="0" tIns="0" rIns="0" bIns="0" anchor="t">
             <a:spAutoFit/>
           </a:bodyPr>
           <a:lstStyle/>
@@ -13263,7 +14002,7 @@
 </file>
 
 <file path=ppt/slides/slide8.xml><?xml version="1.0" encoding="utf-8"?>
-<p:sld xmlns:a="http://schemas.openxmlformats.org/drawingml/2006/main" xmlns:p="http://schemas.openxmlformats.org/presentationml/2006/main" xmlns:r="http://schemas.openxmlformats.org/officeDocument/2006/relationships">
+<p:sld xmlns:a="http://schemas.openxmlformats.org/drawingml/2006/main" xmlns:r="http://schemas.openxmlformats.org/officeDocument/2006/relationships" xmlns:p="http://schemas.openxmlformats.org/presentationml/2006/main">
   <p:cSld>
     <p:bg>
       <p:bgPr>
@@ -13279,7 +14018,14 @@
         <p:cNvGrpSpPr/>
         <p:nvPr/>
       </p:nvGrpSpPr>
-      <p:grpSpPr/>
+      <p:grpSpPr>
+        <a:xfrm>
+          <a:off x="0" y="0"/>
+          <a:ext cx="0" cy="0"/>
+          <a:chOff x="0" y="0"/>
+          <a:chExt cx="0" cy="0"/>
+        </a:xfrm>
+      </p:grpSpPr>
       <p:sp>
         <p:nvSpPr>
           <p:cNvPr id="2" name="TextBox 1"/>
@@ -13297,7 +14043,7 @@
           <a:noFill/>
         </p:spPr>
         <p:txBody>
-          <a:bodyPr wrap="square" anchor="t" lIns="0" rIns="0" tIns="0" bIns="0">
+          <a:bodyPr wrap="square" lIns="0" tIns="0" rIns="0" bIns="0" anchor="t">
             <a:spAutoFit/>
           </a:bodyPr>
           <a:lstStyle/>
@@ -13355,6 +14101,7 @@
           <a:lstStyle/>
           <a:p>
             <a:pPr algn="ctr"/>
+            <a:endParaRPr/>
           </a:p>
         </p:txBody>
       </p:sp>
@@ -13375,7 +14122,7 @@
           <a:noFill/>
         </p:spPr>
         <p:txBody>
-          <a:bodyPr wrap="square" anchor="t" lIns="0" rIns="0" tIns="0" bIns="0">
+          <a:bodyPr wrap="square" lIns="0" tIns="0" rIns="0" bIns="0" anchor="t">
             <a:spAutoFit/>
           </a:bodyPr>
           <a:lstStyle/>
@@ -13491,16 +14238,7 @@
                 </a:solidFill>
                 <a:latin typeface="Roboto"/>
               </a:rPr>
-              <a:t>■  </a:t>
-            </a:r>
-            <a:r>
-              <a:rPr sz="1800" b="1" i="0">
-                <a:solidFill>
-                  <a:srgbClr val="92268F"/>
-                </a:solidFill>
-                <a:latin typeface="Roboto"/>
-              </a:rPr>
-              <a:t>This is the qualitative shortlist — the CBA and risk sections test it next.</a:t>
+              <a:t>■  This is the qualitative shortlist — the CBA and risk sections test it next.</a:t>
             </a:r>
           </a:p>
         </p:txBody>
@@ -13546,6 +14284,7 @@
           <a:lstStyle/>
           <a:p>
             <a:pPr algn="ctr"/>
+            <a:endParaRPr/>
           </a:p>
         </p:txBody>
       </p:sp>
@@ -13566,7 +14305,7 @@
           <a:noFill/>
         </p:spPr>
         <p:txBody>
-          <a:bodyPr wrap="square" anchor="t" lIns="0" rIns="0" tIns="0" bIns="0">
+          <a:bodyPr wrap="square" lIns="0" tIns="0" rIns="0" bIns="0" anchor="t">
             <a:spAutoFit/>
           </a:bodyPr>
           <a:lstStyle/>
@@ -13609,7 +14348,7 @@
           <a:noFill/>
         </p:spPr>
         <p:txBody>
-          <a:bodyPr wrap="square" anchor="t" lIns="0" rIns="0" tIns="0" bIns="0">
+          <a:bodyPr wrap="square" lIns="0" tIns="0" rIns="0" bIns="0" anchor="t">
             <a:spAutoFit/>
           </a:bodyPr>
           <a:lstStyle/>
@@ -13636,7 +14375,7 @@
 </file>
 
 <file path=ppt/slides/slide9.xml><?xml version="1.0" encoding="utf-8"?>
-<p:sld xmlns:a="http://schemas.openxmlformats.org/drawingml/2006/main" xmlns:p="http://schemas.openxmlformats.org/presentationml/2006/main" xmlns:r="http://schemas.openxmlformats.org/officeDocument/2006/relationships">
+<p:sld xmlns:a="http://schemas.openxmlformats.org/drawingml/2006/main" xmlns:r="http://schemas.openxmlformats.org/officeDocument/2006/relationships" xmlns:p="http://schemas.openxmlformats.org/presentationml/2006/main">
   <p:cSld>
     <p:bg>
       <p:bgPr>
@@ -13652,7 +14391,14 @@
         <p:cNvGrpSpPr/>
         <p:nvPr/>
       </p:nvGrpSpPr>
-      <p:grpSpPr/>
+      <p:grpSpPr>
+        <a:xfrm>
+          <a:off x="0" y="0"/>
+          <a:ext cx="0" cy="0"/>
+          <a:chOff x="0" y="0"/>
+          <a:chExt cx="0" cy="0"/>
+        </a:xfrm>
+      </p:grpSpPr>
       <p:sp>
         <p:nvSpPr>
           <p:cNvPr id="2" name="Rectangle 1"/>
@@ -13694,6 +14440,7 @@
           <a:lstStyle/>
           <a:p>
             <a:pPr algn="ctr"/>
+            <a:endParaRPr/>
           </a:p>
         </p:txBody>
       </p:sp>
@@ -13734,7 +14481,7 @@
           </a:fontRef>
         </p:style>
         <p:txBody>
-          <a:bodyPr rtlCol="0" anchor="ctr" wrap="none"/>
+          <a:bodyPr wrap="none" rtlCol="0" anchor="ctr"/>
           <a:lstStyle/>
           <a:p>
             <a:pPr algn="ctr"/>
@@ -13767,7 +14514,7 @@
           <a:noFill/>
         </p:spPr>
         <p:txBody>
-          <a:bodyPr wrap="square" anchor="ctr" lIns="0" rIns="0" tIns="0" bIns="0">
+          <a:bodyPr wrap="square" lIns="0" tIns="0" rIns="0" bIns="0" anchor="ctr">
             <a:spAutoFit/>
           </a:bodyPr>
           <a:lstStyle/>
@@ -13801,7 +14548,7 @@
           <a:noFill/>
         </p:spPr>
         <p:txBody>
-          <a:bodyPr wrap="square" anchor="t" lIns="0" rIns="0" tIns="0" bIns="0">
+          <a:bodyPr wrap="square" lIns="0" tIns="0" rIns="0" bIns="0" anchor="t">
             <a:spAutoFit/>
           </a:bodyPr>
           <a:lstStyle/>
@@ -14067,6 +14814,7 @@
           <a:lstStyle/>
           <a:p>
             <a:pPr algn="ctr"/>
+            <a:endParaRPr/>
           </a:p>
         </p:txBody>
       </p:sp>
@@ -14087,7 +14835,7 @@
           <a:noFill/>
         </p:spPr>
         <p:txBody>
-          <a:bodyPr wrap="square" anchor="ctr" lIns="0" rIns="0" tIns="0" bIns="0">
+          <a:bodyPr wrap="square" lIns="0" tIns="0" rIns="0" bIns="0" anchor="ctr">
             <a:spAutoFit/>
           </a:bodyPr>
           <a:lstStyle/>
@@ -14145,6 +14893,7 @@
           <a:lstStyle/>
           <a:p>
             <a:pPr algn="ctr"/>
+            <a:endParaRPr/>
           </a:p>
         </p:txBody>
       </p:sp>
@@ -14165,7 +14914,7 @@
           <a:noFill/>
         </p:spPr>
         <p:txBody>
-          <a:bodyPr wrap="square" anchor="t" lIns="0" rIns="0" tIns="0" bIns="0">
+          <a:bodyPr wrap="square" lIns="0" tIns="0" rIns="0" bIns="0" anchor="t">
             <a:spAutoFit/>
           </a:bodyPr>
           <a:lstStyle/>
@@ -14208,7 +14957,7 @@
           <a:noFill/>
         </p:spPr>
         <p:txBody>
-          <a:bodyPr wrap="square" anchor="t" lIns="0" rIns="0" tIns="0" bIns="0">
+          <a:bodyPr wrap="square" lIns="0" tIns="0" rIns="0" bIns="0" anchor="t">
             <a:spAutoFit/>
           </a:bodyPr>
           <a:lstStyle/>
@@ -14552,4 +15301,319 @@
   </a:objectDefaults>
   <a:extraClrSchemeLst/>
 </a:theme>
+</file>
+
+<file path=ppt/theme/theme2.xml><?xml version="1.0" encoding="utf-8"?>
+<a:theme xmlns:a="http://schemas.openxmlformats.org/drawingml/2006/main" name="Office Theme">
+  <a:themeElements>
+    <a:clrScheme name="Office">
+      <a:dk1>
+        <a:sysClr val="windowText" lastClr="000000"/>
+      </a:dk1>
+      <a:lt1>
+        <a:sysClr val="window" lastClr="FFFFFF"/>
+      </a:lt1>
+      <a:dk2>
+        <a:srgbClr val="0E2841"/>
+      </a:dk2>
+      <a:lt2>
+        <a:srgbClr val="E8E8E8"/>
+      </a:lt2>
+      <a:accent1>
+        <a:srgbClr val="156082"/>
+      </a:accent1>
+      <a:accent2>
+        <a:srgbClr val="E97132"/>
+      </a:accent2>
+      <a:accent3>
+        <a:srgbClr val="196B24"/>
+      </a:accent3>
+      <a:accent4>
+        <a:srgbClr val="0F9ED5"/>
+      </a:accent4>
+      <a:accent5>
+        <a:srgbClr val="A02B93"/>
+      </a:accent5>
+      <a:accent6>
+        <a:srgbClr val="4EA72E"/>
+      </a:accent6>
+      <a:hlink>
+        <a:srgbClr val="467886"/>
+      </a:hlink>
+      <a:folHlink>
+        <a:srgbClr val="96607D"/>
+      </a:folHlink>
+    </a:clrScheme>
+    <a:fontScheme name="Office">
+      <a:majorFont>
+        <a:latin typeface="Aptos Display" panose="02110004020202020204"/>
+        <a:ea typeface=""/>
+        <a:cs typeface=""/>
+        <a:font script="Jpan" typeface="游ゴシック Light"/>
+        <a:font script="Hang" typeface="맑은 고딕"/>
+        <a:font script="Hans" typeface="等线 Light"/>
+        <a:font script="Hant" typeface="新細明體"/>
+        <a:font script="Arab" typeface="Times New Roman"/>
+        <a:font script="Hebr" typeface="Times New Roman"/>
+        <a:font script="Thai" typeface="Angsana New"/>
+        <a:font script="Ethi" typeface="Nyala"/>
+        <a:font script="Beng" typeface="Vrinda"/>
+        <a:font script="Gujr" typeface="Shruti"/>
+        <a:font script="Khmr" typeface="MoolBoran"/>
+        <a:font script="Knda" typeface="Tunga"/>
+        <a:font script="Guru" typeface="Raavi"/>
+        <a:font script="Cans" typeface="Euphemia"/>
+        <a:font script="Cher" typeface="Plantagenet Cherokee"/>
+        <a:font script="Yiii" typeface="Microsoft Yi Baiti"/>
+        <a:font script="Tibt" typeface="Microsoft Himalaya"/>
+        <a:font script="Thaa" typeface="MV Boli"/>
+        <a:font script="Deva" typeface="Mangal"/>
+        <a:font script="Telu" typeface="Gautami"/>
+        <a:font script="Taml" typeface="Latha"/>
+        <a:font script="Syrc" typeface="Estrangelo Edessa"/>
+        <a:font script="Orya" typeface="Kalinga"/>
+        <a:font script="Mlym" typeface="Kartika"/>
+        <a:font script="Laoo" typeface="DokChampa"/>
+        <a:font script="Sinh" typeface="Iskoola Pota"/>
+        <a:font script="Mong" typeface="Mongolian Baiti"/>
+        <a:font script="Viet" typeface="Times New Roman"/>
+        <a:font script="Uigh" typeface="Microsoft Uighur"/>
+        <a:font script="Geor" typeface="Sylfaen"/>
+        <a:font script="Armn" typeface="Arial"/>
+        <a:font script="Bugi" typeface="Leelawadee UI"/>
+        <a:font script="Bopo" typeface="Microsoft JhengHei"/>
+        <a:font script="Java" typeface="Javanese Text"/>
+        <a:font script="Lisu" typeface="Segoe UI"/>
+        <a:font script="Mymr" typeface="Myanmar Text"/>
+        <a:font script="Nkoo" typeface="Ebrima"/>
+        <a:font script="Olck" typeface="Nirmala UI"/>
+        <a:font script="Osma" typeface="Ebrima"/>
+        <a:font script="Phag" typeface="Phagspa"/>
+        <a:font script="Syrn" typeface="Estrangelo Edessa"/>
+        <a:font script="Syrj" typeface="Estrangelo Edessa"/>
+        <a:font script="Syre" typeface="Estrangelo Edessa"/>
+        <a:font script="Sora" typeface="Nirmala UI"/>
+        <a:font script="Tale" typeface="Microsoft Tai Le"/>
+        <a:font script="Talu" typeface="Microsoft New Tai Lue"/>
+        <a:font script="Tfng" typeface="Ebrima"/>
+      </a:majorFont>
+      <a:minorFont>
+        <a:latin typeface="Aptos" panose="02110004020202020204"/>
+        <a:ea typeface=""/>
+        <a:cs typeface=""/>
+        <a:font script="Jpan" typeface="游ゴシック"/>
+        <a:font script="Hang" typeface="맑은 고딕"/>
+        <a:font script="Hans" typeface="等线"/>
+        <a:font script="Hant" typeface="新細明體"/>
+        <a:font script="Arab" typeface="Arial"/>
+        <a:font script="Hebr" typeface="Arial"/>
+        <a:font script="Thai" typeface="Cordia New"/>
+        <a:font script="Ethi" typeface="Nyala"/>
+        <a:font script="Beng" typeface="Vrinda"/>
+        <a:font script="Gujr" typeface="Shruti"/>
+        <a:font script="Khmr" typeface="DaunPenh"/>
+        <a:font script="Knda" typeface="Tunga"/>
+        <a:font script="Guru" typeface="Raavi"/>
+        <a:font script="Cans" typeface="Euphemia"/>
+        <a:font script="Cher" typeface="Plantagenet Cherokee"/>
+        <a:font script="Yiii" typeface="Microsoft Yi Baiti"/>
+        <a:font script="Tibt" typeface="Microsoft Himalaya"/>
+        <a:font script="Thaa" typeface="MV Boli"/>
+        <a:font script="Deva" typeface="Mangal"/>
+        <a:font script="Telu" typeface="Gautami"/>
+        <a:font script="Taml" typeface="Latha"/>
+        <a:font script="Syrc" typeface="Estrangelo Edessa"/>
+        <a:font script="Orya" typeface="Kalinga"/>
+        <a:font script="Mlym" typeface="Kartika"/>
+        <a:font script="Laoo" typeface="DokChampa"/>
+        <a:font script="Sinh" typeface="Iskoola Pota"/>
+        <a:font script="Mong" typeface="Mongolian Baiti"/>
+        <a:font script="Viet" typeface="Arial"/>
+        <a:font script="Uigh" typeface="Microsoft Uighur"/>
+        <a:font script="Geor" typeface="Sylfaen"/>
+        <a:font script="Armn" typeface="Arial"/>
+        <a:font script="Bugi" typeface="Leelawadee UI"/>
+        <a:font script="Bopo" typeface="Microsoft JhengHei"/>
+        <a:font script="Java" typeface="Javanese Text"/>
+        <a:font script="Lisu" typeface="Segoe UI"/>
+        <a:font script="Mymr" typeface="Myanmar Text"/>
+        <a:font script="Nkoo" typeface="Ebrima"/>
+        <a:font script="Olck" typeface="Nirmala UI"/>
+        <a:font script="Osma" typeface="Ebrima"/>
+        <a:font script="Phag" typeface="Phagspa"/>
+        <a:font script="Syrn" typeface="Estrangelo Edessa"/>
+        <a:font script="Syrj" typeface="Estrangelo Edessa"/>
+        <a:font script="Syre" typeface="Estrangelo Edessa"/>
+        <a:font script="Sora" typeface="Nirmala UI"/>
+        <a:font script="Tale" typeface="Microsoft Tai Le"/>
+        <a:font script="Talu" typeface="Microsoft New Tai Lue"/>
+        <a:font script="Tfng" typeface="Ebrima"/>
+      </a:minorFont>
+    </a:fontScheme>
+    <a:fmtScheme name="Office">
+      <a:fillStyleLst>
+        <a:solidFill>
+          <a:schemeClr val="phClr"/>
+        </a:solidFill>
+        <a:gradFill rotWithShape="1">
+          <a:gsLst>
+            <a:gs pos="0">
+              <a:schemeClr val="phClr">
+                <a:lumMod val="110000"/>
+                <a:satMod val="105000"/>
+                <a:tint val="67000"/>
+              </a:schemeClr>
+            </a:gs>
+            <a:gs pos="50000">
+              <a:schemeClr val="phClr">
+                <a:lumMod val="105000"/>
+                <a:satMod val="103000"/>
+                <a:tint val="73000"/>
+              </a:schemeClr>
+            </a:gs>
+            <a:gs pos="100000">
+              <a:schemeClr val="phClr">
+                <a:lumMod val="105000"/>
+                <a:satMod val="109000"/>
+                <a:tint val="81000"/>
+              </a:schemeClr>
+            </a:gs>
+          </a:gsLst>
+          <a:lin ang="5400000" scaled="0"/>
+        </a:gradFill>
+        <a:gradFill rotWithShape="1">
+          <a:gsLst>
+            <a:gs pos="0">
+              <a:schemeClr val="phClr">
+                <a:satMod val="103000"/>
+                <a:lumMod val="102000"/>
+                <a:tint val="94000"/>
+              </a:schemeClr>
+            </a:gs>
+            <a:gs pos="50000">
+              <a:schemeClr val="phClr">
+                <a:satMod val="110000"/>
+                <a:lumMod val="100000"/>
+                <a:shade val="100000"/>
+              </a:schemeClr>
+            </a:gs>
+            <a:gs pos="100000">
+              <a:schemeClr val="phClr">
+                <a:lumMod val="99000"/>
+                <a:satMod val="120000"/>
+                <a:shade val="78000"/>
+              </a:schemeClr>
+            </a:gs>
+          </a:gsLst>
+          <a:lin ang="5400000" scaled="0"/>
+        </a:gradFill>
+      </a:fillStyleLst>
+      <a:lnStyleLst>
+        <a:ln w="12700" cap="flat" cmpd="sng" algn="ctr">
+          <a:solidFill>
+            <a:schemeClr val="phClr"/>
+          </a:solidFill>
+          <a:prstDash val="solid"/>
+          <a:miter lim="800000"/>
+        </a:ln>
+        <a:ln w="19050" cap="flat" cmpd="sng" algn="ctr">
+          <a:solidFill>
+            <a:schemeClr val="phClr"/>
+          </a:solidFill>
+          <a:prstDash val="solid"/>
+          <a:miter lim="800000"/>
+        </a:ln>
+        <a:ln w="25400" cap="flat" cmpd="sng" algn="ctr">
+          <a:solidFill>
+            <a:schemeClr val="phClr"/>
+          </a:solidFill>
+          <a:prstDash val="solid"/>
+          <a:miter lim="800000"/>
+        </a:ln>
+      </a:lnStyleLst>
+      <a:effectStyleLst>
+        <a:effectStyle>
+          <a:effectLst/>
+        </a:effectStyle>
+        <a:effectStyle>
+          <a:effectLst/>
+        </a:effectStyle>
+        <a:effectStyle>
+          <a:effectLst>
+            <a:outerShdw blurRad="57150" dist="19050" dir="5400000" algn="ctr" rotWithShape="0">
+              <a:srgbClr val="000000">
+                <a:alpha val="63000"/>
+              </a:srgbClr>
+            </a:outerShdw>
+          </a:effectLst>
+        </a:effectStyle>
+      </a:effectStyleLst>
+      <a:bgFillStyleLst>
+        <a:solidFill>
+          <a:schemeClr val="phClr"/>
+        </a:solidFill>
+        <a:solidFill>
+          <a:schemeClr val="phClr">
+            <a:tint val="95000"/>
+            <a:satMod val="170000"/>
+          </a:schemeClr>
+        </a:solidFill>
+        <a:gradFill rotWithShape="1">
+          <a:gsLst>
+            <a:gs pos="0">
+              <a:schemeClr val="phClr">
+                <a:tint val="93000"/>
+                <a:satMod val="150000"/>
+                <a:shade val="98000"/>
+                <a:lumMod val="102000"/>
+              </a:schemeClr>
+            </a:gs>
+            <a:gs pos="50000">
+              <a:schemeClr val="phClr">
+                <a:tint val="98000"/>
+                <a:satMod val="130000"/>
+                <a:shade val="90000"/>
+                <a:lumMod val="103000"/>
+              </a:schemeClr>
+            </a:gs>
+            <a:gs pos="100000">
+              <a:schemeClr val="phClr">
+                <a:shade val="63000"/>
+                <a:satMod val="120000"/>
+              </a:schemeClr>
+            </a:gs>
+          </a:gsLst>
+          <a:lin ang="5400000" scaled="0"/>
+        </a:gradFill>
+      </a:bgFillStyleLst>
+    </a:fmtScheme>
+  </a:themeElements>
+  <a:objectDefaults>
+    <a:lnDef>
+      <a:spPr/>
+      <a:bodyPr/>
+      <a:lstStyle/>
+      <a:style>
+        <a:lnRef idx="2">
+          <a:schemeClr val="accent1"/>
+        </a:lnRef>
+        <a:fillRef idx="0">
+          <a:schemeClr val="accent1"/>
+        </a:fillRef>
+        <a:effectRef idx="1">
+          <a:schemeClr val="accent1"/>
+        </a:effectRef>
+        <a:fontRef idx="minor">
+          <a:schemeClr val="tx1"/>
+        </a:fontRef>
+      </a:style>
+    </a:lnDef>
+  </a:objectDefaults>
+  <a:extraClrSchemeLst/>
+  <a:extLst>
+    <a:ext uri="{05A4C25C-085E-4340-85A3-A5531E510DB2}">
+      <thm15:themeFamily xmlns:thm15="http://schemas.microsoft.com/office/thememl/2012/main" name="Office Theme" id="{2E142A2C-CD16-42D6-873A-C26D2A0506FA}" vid="{1BDDFF52-6CD6-40A5-AB3C-68EB2F1E4D0A}"/>
+    </a:ext>
+  </a:extLst>
+</a:theme>
 </file>
</xml_diff>